<commit_message>
feat: expand defense ppt to 15 concise slides
Agent-Logs-Url: https://github.com/cxkqq/Student_Exam/sessions/00395ad2-041c-445a-91c8-7caedc14cd4b

Co-authored-by: cxkqq <119168655+cxkqq@users.noreply.github.com>
</commit_message>
<xml_diff>
--- a/defense_ppt.pptx
+++ b/defense_ppt.pptx
@@ -15,6 +15,11 @@
     <p:sldId id="263" r:id="rId14"/>
     <p:sldId id="264" r:id="rId15"/>
     <p:sldId id="265" r:id="rId16"/>
+    <p:sldId id="266" r:id="rId17"/>
+    <p:sldId id="267" r:id="rId18"/>
+    <p:sldId id="268" r:id="rId19"/>
+    <p:sldId id="269" r:id="rId20"/>
+    <p:sldId id="270" r:id="rId21"/>
   </p:sldIdLst>
   <p:sldSz cx="12191695" cy="6858000" type="screen4x3"/>
   <p:notesSz cx="6858000" cy="9144000"/>
@@ -3149,13 +3154,13 @@
         <p:spPr>
           <a:xfrm>
             <a:off x="0" y="0"/>
-            <a:ext cx="12191695" cy="502920"/>
+            <a:ext cx="12191695" cy="438912"/>
           </a:xfrm>
           <a:prstGeom prst="rect">
             <a:avLst/>
           </a:prstGeom>
           <a:solidFill>
-            <a:srgbClr val="20253A"/>
+            <a:srgbClr val="22293F"/>
           </a:solidFill>
           <a:ln>
             <a:noFill/>
@@ -3191,8 +3196,8 @@
         </p:nvSpPr>
         <p:spPr>
           <a:xfrm>
-            <a:off x="731520" y="960120"/>
-            <a:ext cx="10789920" cy="5349240"/>
+            <a:off x="822960" y="914400"/>
+            <a:ext cx="10515600" cy="5303520"/>
           </a:xfrm>
           <a:prstGeom prst="roundRect">
             <a:avLst/>
@@ -3227,7 +3232,7 @@
             <a:pPr algn="ctr">
               <a:defRPr sz="4200" b="1">
                 <a:solidFill>
-                  <a:srgbClr val="20253A"/>
+                  <a:srgbClr val="22293F"/>
                 </a:solidFill>
               </a:defRPr>
             </a:pPr>
@@ -3237,9 +3242,9 @@
           </a:p>
           <a:p>
             <a:pPr algn="ctr">
-              <a:defRPr sz="2600">
-                <a:solidFill>
-                  <a:srgbClr val="2850A0"/>
+              <a:defRPr sz="2800">
+                <a:solidFill>
+                  <a:srgbClr val="3166BE"/>
                 </a:solidFill>
               </a:defRPr>
             </a:pPr>
@@ -3251,12 +3256,12 @@
             <a:pPr algn="ctr">
               <a:defRPr sz="1800">
                 <a:solidFill>
-                  <a:srgbClr val="373737"/>
-                </a:solidFill>
-              </a:defRPr>
-            </a:pPr>
-            <a:r>
-              <a:t>Student_Exam 项目</a:t>
+                  <a:srgbClr val="464646"/>
+                </a:solidFill>
+              </a:defRPr>
+            </a:pPr>
+            <a:r>
+              <a:t>Student_Exam</a:t>
             </a:r>
           </a:p>
         </p:txBody>
@@ -3331,13 +3336,13 @@
         <p:spPr>
           <a:xfrm>
             <a:off x="0" y="0"/>
-            <a:ext cx="12191695" cy="502920"/>
+            <a:ext cx="12191695" cy="438912"/>
           </a:xfrm>
           <a:prstGeom prst="rect">
             <a:avLst/>
           </a:prstGeom>
           <a:solidFill>
-            <a:srgbClr val="20253A"/>
+            <a:srgbClr val="22293F"/>
           </a:solidFill>
           <a:ln>
             <a:noFill/>
@@ -3367,14 +3372,459 @@
       </p:sp>
       <p:sp>
         <p:nvSpPr>
-          <p:cNvPr id="4" name="Rounded Rectangle 3"/>
+          <p:cNvPr id="4" name="TextBox 3"/>
+          <p:cNvSpPr txBox="1"/>
+          <p:nvPr/>
+        </p:nvSpPr>
+        <p:spPr>
+          <a:xfrm>
+            <a:off x="640080" y="603504"/>
+            <a:ext cx="10972800" cy="914400"/>
+          </a:xfrm>
+          <a:prstGeom prst="rect">
+            <a:avLst/>
+          </a:prstGeom>
+          <a:noFill/>
+        </p:spPr>
+        <p:txBody>
+          <a:bodyPr wrap="none">
+            <a:spAutoFit/>
+          </a:bodyPr>
+          <a:lstStyle/>
+          <a:p>
+            <a:pPr>
+              <a:defRPr sz="3400" b="1">
+                <a:solidFill>
+                  <a:srgbClr val="22293F"/>
+                </a:solidFill>
+              </a:defRPr>
+            </a:pPr>
+            <a:r>
+              <a:t>教师端：成绩录入</a:t>
+            </a:r>
+          </a:p>
+        </p:txBody>
+      </p:sp>
+      <p:sp>
+        <p:nvSpPr>
+          <p:cNvPr id="5" name="Rounded Rectangle 4"/>
           <p:cNvSpPr/>
           <p:nvPr/>
         </p:nvSpPr>
         <p:spPr>
           <a:xfrm>
-            <a:off x="914400" y="1097280"/>
-            <a:ext cx="10332720" cy="4754880"/>
+            <a:off x="731520" y="1645920"/>
+            <a:ext cx="10789920" cy="4754880"/>
+          </a:xfrm>
+          <a:prstGeom prst="roundRect">
+            <a:avLst/>
+          </a:prstGeom>
+          <a:solidFill>
+            <a:srgbClr val="E8ECF5"/>
+          </a:solidFill>
+          <a:ln>
+            <a:solidFill>
+              <a:srgbClr val="BEC6DC"/>
+            </a:solidFill>
+          </a:ln>
+        </p:spPr>
+        <p:style>
+          <a:lnRef idx="1">
+            <a:schemeClr val="accent1"/>
+          </a:lnRef>
+          <a:fillRef idx="3">
+            <a:schemeClr val="accent1"/>
+          </a:fillRef>
+          <a:effectRef idx="2">
+            <a:schemeClr val="accent1"/>
+          </a:effectRef>
+          <a:fontRef idx="minor">
+            <a:schemeClr val="lt1"/>
+          </a:fontRef>
+        </p:style>
+        <p:txBody>
+          <a:bodyPr rtlCol="0" anchor="ctr"/>
+          <a:lstStyle/>
+          <a:p>
+            <a:pPr algn="ctr">
+              <a:defRPr b="1" sz="1800">
+                <a:solidFill>
+                  <a:srgbClr val="22293F"/>
+                </a:solidFill>
+              </a:defRPr>
+            </a:pPr>
+            <a:r>
+              <a:t>待插入：成绩录入</a:t>
+            </a:r>
+          </a:p>
+          <a:p>
+            <a:pPr algn="ctr">
+              <a:defRPr sz="900">
+                <a:solidFill>
+                  <a:srgbClr val="464646"/>
+                </a:solidFill>
+              </a:defRPr>
+            </a:pPr>
+            <a:r>
+              <a:t>https://github.com/user-attachments/assets/94de7b8c-ff84-47ab-ab47-2a2df7e89495</a:t>
+            </a:r>
+          </a:p>
+        </p:txBody>
+      </p:sp>
+    </p:spTree>
+  </p:cSld>
+  <p:clrMapOvr>
+    <a:masterClrMapping/>
+  </p:clrMapOvr>
+</p:sld>
+</file>
+
+<file path=ppt/slides/slide11.xml><?xml version="1.0" encoding="utf-8"?>
+<p:sld xmlns:a="http://schemas.openxmlformats.org/drawingml/2006/main" xmlns:p="http://schemas.openxmlformats.org/presentationml/2006/main" xmlns:r="http://schemas.openxmlformats.org/officeDocument/2006/relationships">
+  <p:cSld>
+    <p:spTree>
+      <p:nvGrpSpPr>
+        <p:cNvPr id="1" name=""/>
+        <p:cNvGrpSpPr/>
+        <p:nvPr/>
+      </p:nvGrpSpPr>
+      <p:grpSpPr/>
+      <p:sp>
+        <p:nvSpPr>
+          <p:cNvPr id="2" name="Rectangle 1"/>
+          <p:cNvSpPr/>
+          <p:nvPr/>
+        </p:nvSpPr>
+        <p:spPr>
+          <a:xfrm>
+            <a:off x="0" y="0"/>
+            <a:ext cx="12191695" cy="6858000"/>
+          </a:xfrm>
+          <a:prstGeom prst="rect">
+            <a:avLst/>
+          </a:prstGeom>
+          <a:solidFill>
+            <a:srgbClr val="F6F8FC"/>
+          </a:solidFill>
+          <a:ln>
+            <a:noFill/>
+          </a:ln>
+        </p:spPr>
+        <p:style>
+          <a:lnRef idx="1">
+            <a:schemeClr val="accent1"/>
+          </a:lnRef>
+          <a:fillRef idx="3">
+            <a:schemeClr val="accent1"/>
+          </a:fillRef>
+          <a:effectRef idx="2">
+            <a:schemeClr val="accent1"/>
+          </a:effectRef>
+          <a:fontRef idx="minor">
+            <a:schemeClr val="lt1"/>
+          </a:fontRef>
+        </p:style>
+        <p:txBody>
+          <a:bodyPr rtlCol="0" anchor="ctr"/>
+          <a:lstStyle/>
+          <a:p>
+            <a:pPr algn="ctr"/>
+          </a:p>
+        </p:txBody>
+      </p:sp>
+      <p:sp>
+        <p:nvSpPr>
+          <p:cNvPr id="3" name="Rectangle 2"/>
+          <p:cNvSpPr/>
+          <p:nvPr/>
+        </p:nvSpPr>
+        <p:spPr>
+          <a:xfrm>
+            <a:off x="0" y="0"/>
+            <a:ext cx="12191695" cy="438912"/>
+          </a:xfrm>
+          <a:prstGeom prst="rect">
+            <a:avLst/>
+          </a:prstGeom>
+          <a:solidFill>
+            <a:srgbClr val="22293F"/>
+          </a:solidFill>
+          <a:ln>
+            <a:noFill/>
+          </a:ln>
+        </p:spPr>
+        <p:style>
+          <a:lnRef idx="1">
+            <a:schemeClr val="accent1"/>
+          </a:lnRef>
+          <a:fillRef idx="3">
+            <a:schemeClr val="accent1"/>
+          </a:fillRef>
+          <a:effectRef idx="2">
+            <a:schemeClr val="accent1"/>
+          </a:effectRef>
+          <a:fontRef idx="minor">
+            <a:schemeClr val="lt1"/>
+          </a:fontRef>
+        </p:style>
+        <p:txBody>
+          <a:bodyPr rtlCol="0" anchor="ctr"/>
+          <a:lstStyle/>
+          <a:p>
+            <a:pPr algn="ctr"/>
+          </a:p>
+        </p:txBody>
+      </p:sp>
+      <p:sp>
+        <p:nvSpPr>
+          <p:cNvPr id="4" name="TextBox 3"/>
+          <p:cNvSpPr txBox="1"/>
+          <p:nvPr/>
+        </p:nvSpPr>
+        <p:spPr>
+          <a:xfrm>
+            <a:off x="640080" y="603504"/>
+            <a:ext cx="10972800" cy="914400"/>
+          </a:xfrm>
+          <a:prstGeom prst="rect">
+            <a:avLst/>
+          </a:prstGeom>
+          <a:noFill/>
+        </p:spPr>
+        <p:txBody>
+          <a:bodyPr wrap="none">
+            <a:spAutoFit/>
+          </a:bodyPr>
+          <a:lstStyle/>
+          <a:p>
+            <a:pPr>
+              <a:defRPr sz="3400" b="1">
+                <a:solidFill>
+                  <a:srgbClr val="22293F"/>
+                </a:solidFill>
+              </a:defRPr>
+            </a:pPr>
+            <a:r>
+              <a:t>教师端：考勤管理</a:t>
+            </a:r>
+          </a:p>
+        </p:txBody>
+      </p:sp>
+      <p:sp>
+        <p:nvSpPr>
+          <p:cNvPr id="5" name="Rounded Rectangle 4"/>
+          <p:cNvSpPr/>
+          <p:nvPr/>
+        </p:nvSpPr>
+        <p:spPr>
+          <a:xfrm>
+            <a:off x="731520" y="1645920"/>
+            <a:ext cx="10789920" cy="4754880"/>
+          </a:xfrm>
+          <a:prstGeom prst="roundRect">
+            <a:avLst/>
+          </a:prstGeom>
+          <a:solidFill>
+            <a:srgbClr val="E8ECF5"/>
+          </a:solidFill>
+          <a:ln>
+            <a:solidFill>
+              <a:srgbClr val="BEC6DC"/>
+            </a:solidFill>
+          </a:ln>
+        </p:spPr>
+        <p:style>
+          <a:lnRef idx="1">
+            <a:schemeClr val="accent1"/>
+          </a:lnRef>
+          <a:fillRef idx="3">
+            <a:schemeClr val="accent1"/>
+          </a:fillRef>
+          <a:effectRef idx="2">
+            <a:schemeClr val="accent1"/>
+          </a:effectRef>
+          <a:fontRef idx="minor">
+            <a:schemeClr val="lt1"/>
+          </a:fontRef>
+        </p:style>
+        <p:txBody>
+          <a:bodyPr rtlCol="0" anchor="ctr"/>
+          <a:lstStyle/>
+          <a:p>
+            <a:pPr algn="ctr">
+              <a:defRPr b="1" sz="1800">
+                <a:solidFill>
+                  <a:srgbClr val="22293F"/>
+                </a:solidFill>
+              </a:defRPr>
+            </a:pPr>
+            <a:r>
+              <a:t>待插入：考勤管理</a:t>
+            </a:r>
+          </a:p>
+          <a:p>
+            <a:pPr algn="ctr">
+              <a:defRPr sz="900">
+                <a:solidFill>
+                  <a:srgbClr val="464646"/>
+                </a:solidFill>
+              </a:defRPr>
+            </a:pPr>
+            <a:r>
+              <a:t>https://github.com/user-attachments/assets/4d44de09-7e1b-455e-9dbd-b06c2b20031b</a:t>
+            </a:r>
+          </a:p>
+        </p:txBody>
+      </p:sp>
+    </p:spTree>
+  </p:cSld>
+  <p:clrMapOvr>
+    <a:masterClrMapping/>
+  </p:clrMapOvr>
+</p:sld>
+</file>
+
+<file path=ppt/slides/slide12.xml><?xml version="1.0" encoding="utf-8"?>
+<p:sld xmlns:a="http://schemas.openxmlformats.org/drawingml/2006/main" xmlns:p="http://schemas.openxmlformats.org/presentationml/2006/main" xmlns:r="http://schemas.openxmlformats.org/officeDocument/2006/relationships">
+  <p:cSld>
+    <p:spTree>
+      <p:nvGrpSpPr>
+        <p:cNvPr id="1" name=""/>
+        <p:cNvGrpSpPr/>
+        <p:nvPr/>
+      </p:nvGrpSpPr>
+      <p:grpSpPr/>
+      <p:sp>
+        <p:nvSpPr>
+          <p:cNvPr id="2" name="Rectangle 1"/>
+          <p:cNvSpPr/>
+          <p:nvPr/>
+        </p:nvSpPr>
+        <p:spPr>
+          <a:xfrm>
+            <a:off x="0" y="0"/>
+            <a:ext cx="12191695" cy="6858000"/>
+          </a:xfrm>
+          <a:prstGeom prst="rect">
+            <a:avLst/>
+          </a:prstGeom>
+          <a:solidFill>
+            <a:srgbClr val="F6F8FC"/>
+          </a:solidFill>
+          <a:ln>
+            <a:noFill/>
+          </a:ln>
+        </p:spPr>
+        <p:style>
+          <a:lnRef idx="1">
+            <a:schemeClr val="accent1"/>
+          </a:lnRef>
+          <a:fillRef idx="3">
+            <a:schemeClr val="accent1"/>
+          </a:fillRef>
+          <a:effectRef idx="2">
+            <a:schemeClr val="accent1"/>
+          </a:effectRef>
+          <a:fontRef idx="minor">
+            <a:schemeClr val="lt1"/>
+          </a:fontRef>
+        </p:style>
+        <p:txBody>
+          <a:bodyPr rtlCol="0" anchor="ctr"/>
+          <a:lstStyle/>
+          <a:p>
+            <a:pPr algn="ctr"/>
+          </a:p>
+        </p:txBody>
+      </p:sp>
+      <p:sp>
+        <p:nvSpPr>
+          <p:cNvPr id="3" name="Rectangle 2"/>
+          <p:cNvSpPr/>
+          <p:nvPr/>
+        </p:nvSpPr>
+        <p:spPr>
+          <a:xfrm>
+            <a:off x="0" y="0"/>
+            <a:ext cx="12191695" cy="438912"/>
+          </a:xfrm>
+          <a:prstGeom prst="rect">
+            <a:avLst/>
+          </a:prstGeom>
+          <a:solidFill>
+            <a:srgbClr val="22293F"/>
+          </a:solidFill>
+          <a:ln>
+            <a:noFill/>
+          </a:ln>
+        </p:spPr>
+        <p:style>
+          <a:lnRef idx="1">
+            <a:schemeClr val="accent1"/>
+          </a:lnRef>
+          <a:fillRef idx="3">
+            <a:schemeClr val="accent1"/>
+          </a:fillRef>
+          <a:effectRef idx="2">
+            <a:schemeClr val="accent1"/>
+          </a:effectRef>
+          <a:fontRef idx="minor">
+            <a:schemeClr val="lt1"/>
+          </a:fontRef>
+        </p:style>
+        <p:txBody>
+          <a:bodyPr rtlCol="0" anchor="ctr"/>
+          <a:lstStyle/>
+          <a:p>
+            <a:pPr algn="ctr"/>
+          </a:p>
+        </p:txBody>
+      </p:sp>
+      <p:sp>
+        <p:nvSpPr>
+          <p:cNvPr id="4" name="TextBox 3"/>
+          <p:cNvSpPr txBox="1"/>
+          <p:nvPr/>
+        </p:nvSpPr>
+        <p:spPr>
+          <a:xfrm>
+            <a:off x="640080" y="603504"/>
+            <a:ext cx="10972800" cy="914400"/>
+          </a:xfrm>
+          <a:prstGeom prst="rect">
+            <a:avLst/>
+          </a:prstGeom>
+          <a:noFill/>
+        </p:spPr>
+        <p:txBody>
+          <a:bodyPr wrap="none">
+            <a:spAutoFit/>
+          </a:bodyPr>
+          <a:lstStyle/>
+          <a:p>
+            <a:pPr>
+              <a:defRPr sz="3400" b="1">
+                <a:solidFill>
+                  <a:srgbClr val="22293F"/>
+                </a:solidFill>
+              </a:defRPr>
+            </a:pPr>
+            <a:r>
+              <a:t>教师端流程闭环总结</a:t>
+            </a:r>
+          </a:p>
+        </p:txBody>
+      </p:sp>
+      <p:sp>
+        <p:nvSpPr>
+          <p:cNvPr id="5" name="Rounded Rectangle 4"/>
+          <p:cNvSpPr/>
+          <p:nvPr/>
+        </p:nvSpPr>
+        <p:spPr>
+          <a:xfrm>
+            <a:off x="822960" y="1691640"/>
+            <a:ext cx="5303520" cy="4480560"/>
           </a:xfrm>
           <a:prstGeom prst="roundRect">
             <a:avLst/>
@@ -3407,9 +3857,907 @@
           <a:lstStyle/>
           <a:p>
             <a:pPr algn="ctr">
-              <a:defRPr b="1" sz="3600">
-                <a:solidFill>
-                  <a:srgbClr val="20253A"/>
+              <a:defRPr sz="2200" b="1">
+                <a:solidFill>
+                  <a:srgbClr val="22293F"/>
+                </a:solidFill>
+              </a:defRPr>
+            </a:pPr>
+            <a:r>
+              <a:t>完整流程</a:t>
+            </a:r>
+          </a:p>
+          <a:p>
+            <a:pPr>
+              <a:defRPr sz="1700">
+                <a:solidFill>
+                  <a:srgbClr val="464646"/>
+                </a:solidFill>
+              </a:defRPr>
+            </a:pPr>
+            <a:r>
+              <a:t>课程创建</a:t>
+            </a:r>
+          </a:p>
+          <a:p>
+            <a:pPr>
+              <a:defRPr sz="1700">
+                <a:solidFill>
+                  <a:srgbClr val="464646"/>
+                </a:solidFill>
+              </a:defRPr>
+            </a:pPr>
+            <a:r>
+              <a:t>学生参与</a:t>
+            </a:r>
+          </a:p>
+          <a:p>
+            <a:pPr>
+              <a:defRPr sz="1700">
+                <a:solidFill>
+                  <a:srgbClr val="464646"/>
+                </a:solidFill>
+              </a:defRPr>
+            </a:pPr>
+            <a:r>
+              <a:t>成绩记录</a:t>
+            </a:r>
+          </a:p>
+          <a:p>
+            <a:pPr>
+              <a:defRPr sz="1700">
+                <a:solidFill>
+                  <a:srgbClr val="464646"/>
+                </a:solidFill>
+              </a:defRPr>
+            </a:pPr>
+            <a:r>
+              <a:t>考勤记录</a:t>
+            </a:r>
+          </a:p>
+          <a:p>
+            <a:pPr>
+              <a:defRPr sz="1700">
+                <a:solidFill>
+                  <a:srgbClr val="464646"/>
+                </a:solidFill>
+              </a:defRPr>
+            </a:pPr>
+            <a:r>
+              <a:t>过程复盘</a:t>
+            </a:r>
+          </a:p>
+        </p:txBody>
+      </p:sp>
+      <p:sp>
+        <p:nvSpPr>
+          <p:cNvPr id="6" name="Rounded Rectangle 5"/>
+          <p:cNvSpPr/>
+          <p:nvPr/>
+        </p:nvSpPr>
+        <p:spPr>
+          <a:xfrm>
+            <a:off x="6035040" y="1691640"/>
+            <a:ext cx="5303520" cy="4480560"/>
+          </a:xfrm>
+          <a:prstGeom prst="roundRect">
+            <a:avLst/>
+          </a:prstGeom>
+          <a:solidFill>
+            <a:srgbClr val="FFFFFF"/>
+          </a:solidFill>
+          <a:ln>
+            <a:solidFill>
+              <a:srgbClr val="DCE2F0"/>
+            </a:solidFill>
+          </a:ln>
+        </p:spPr>
+        <p:style>
+          <a:lnRef idx="1">
+            <a:schemeClr val="accent1"/>
+          </a:lnRef>
+          <a:fillRef idx="3">
+            <a:schemeClr val="accent1"/>
+          </a:fillRef>
+          <a:effectRef idx="2">
+            <a:schemeClr val="accent1"/>
+          </a:effectRef>
+          <a:fontRef idx="minor">
+            <a:schemeClr val="lt1"/>
+          </a:fontRef>
+        </p:style>
+        <p:txBody>
+          <a:bodyPr rtlCol="0" anchor="ctr"/>
+          <a:lstStyle/>
+          <a:p>
+            <a:pPr algn="ctr">
+              <a:defRPr sz="2200" b="1">
+                <a:solidFill>
+                  <a:srgbClr val="22293F"/>
+                </a:solidFill>
+              </a:defRPr>
+            </a:pPr>
+            <a:r>
+              <a:t>成效</a:t>
+            </a:r>
+          </a:p>
+          <a:p>
+            <a:pPr>
+              <a:defRPr sz="1700">
+                <a:solidFill>
+                  <a:srgbClr val="464646"/>
+                </a:solidFill>
+              </a:defRPr>
+            </a:pPr>
+            <a:r>
+              <a:t>规范教学活动过程</a:t>
+            </a:r>
+          </a:p>
+          <a:p>
+            <a:pPr>
+              <a:defRPr sz="1700">
+                <a:solidFill>
+                  <a:srgbClr val="464646"/>
+                </a:solidFill>
+              </a:defRPr>
+            </a:pPr>
+            <a:r>
+              <a:t>降低线下统计工作量</a:t>
+            </a:r>
+          </a:p>
+          <a:p>
+            <a:pPr>
+              <a:defRPr sz="1700">
+                <a:solidFill>
+                  <a:srgbClr val="464646"/>
+                </a:solidFill>
+              </a:defRPr>
+            </a:pPr>
+            <a:r>
+              <a:t>沉淀可追踪教学数据</a:t>
+            </a:r>
+          </a:p>
+        </p:txBody>
+      </p:sp>
+    </p:spTree>
+  </p:cSld>
+  <p:clrMapOvr>
+    <a:masterClrMapping/>
+  </p:clrMapOvr>
+</p:sld>
+</file>
+
+<file path=ppt/slides/slide13.xml><?xml version="1.0" encoding="utf-8"?>
+<p:sld xmlns:a="http://schemas.openxmlformats.org/drawingml/2006/main" xmlns:p="http://schemas.openxmlformats.org/presentationml/2006/main" xmlns:r="http://schemas.openxmlformats.org/officeDocument/2006/relationships">
+  <p:cSld>
+    <p:spTree>
+      <p:nvGrpSpPr>
+        <p:cNvPr id="1" name=""/>
+        <p:cNvGrpSpPr/>
+        <p:nvPr/>
+      </p:nvGrpSpPr>
+      <p:grpSpPr/>
+      <p:sp>
+        <p:nvSpPr>
+          <p:cNvPr id="2" name="Rectangle 1"/>
+          <p:cNvSpPr/>
+          <p:nvPr/>
+        </p:nvSpPr>
+        <p:spPr>
+          <a:xfrm>
+            <a:off x="0" y="0"/>
+            <a:ext cx="12191695" cy="6858000"/>
+          </a:xfrm>
+          <a:prstGeom prst="rect">
+            <a:avLst/>
+          </a:prstGeom>
+          <a:solidFill>
+            <a:srgbClr val="F6F8FC"/>
+          </a:solidFill>
+          <a:ln>
+            <a:noFill/>
+          </a:ln>
+        </p:spPr>
+        <p:style>
+          <a:lnRef idx="1">
+            <a:schemeClr val="accent1"/>
+          </a:lnRef>
+          <a:fillRef idx="3">
+            <a:schemeClr val="accent1"/>
+          </a:fillRef>
+          <a:effectRef idx="2">
+            <a:schemeClr val="accent1"/>
+          </a:effectRef>
+          <a:fontRef idx="minor">
+            <a:schemeClr val="lt1"/>
+          </a:fontRef>
+        </p:style>
+        <p:txBody>
+          <a:bodyPr rtlCol="0" anchor="ctr"/>
+          <a:lstStyle/>
+          <a:p>
+            <a:pPr algn="ctr"/>
+          </a:p>
+        </p:txBody>
+      </p:sp>
+      <p:sp>
+        <p:nvSpPr>
+          <p:cNvPr id="3" name="Rectangle 2"/>
+          <p:cNvSpPr/>
+          <p:nvPr/>
+        </p:nvSpPr>
+        <p:spPr>
+          <a:xfrm>
+            <a:off x="0" y="0"/>
+            <a:ext cx="12191695" cy="438912"/>
+          </a:xfrm>
+          <a:prstGeom prst="rect">
+            <a:avLst/>
+          </a:prstGeom>
+          <a:solidFill>
+            <a:srgbClr val="22293F"/>
+          </a:solidFill>
+          <a:ln>
+            <a:noFill/>
+          </a:ln>
+        </p:spPr>
+        <p:style>
+          <a:lnRef idx="1">
+            <a:schemeClr val="accent1"/>
+          </a:lnRef>
+          <a:fillRef idx="3">
+            <a:schemeClr val="accent1"/>
+          </a:fillRef>
+          <a:effectRef idx="2">
+            <a:schemeClr val="accent1"/>
+          </a:effectRef>
+          <a:fontRef idx="minor">
+            <a:schemeClr val="lt1"/>
+          </a:fontRef>
+        </p:style>
+        <p:txBody>
+          <a:bodyPr rtlCol="0" anchor="ctr"/>
+          <a:lstStyle/>
+          <a:p>
+            <a:pPr algn="ctr"/>
+          </a:p>
+        </p:txBody>
+      </p:sp>
+      <p:sp>
+        <p:nvSpPr>
+          <p:cNvPr id="4" name="TextBox 3"/>
+          <p:cNvSpPr txBox="1"/>
+          <p:nvPr/>
+        </p:nvSpPr>
+        <p:spPr>
+          <a:xfrm>
+            <a:off x="640080" y="603504"/>
+            <a:ext cx="10972800" cy="914400"/>
+          </a:xfrm>
+          <a:prstGeom prst="rect">
+            <a:avLst/>
+          </a:prstGeom>
+          <a:noFill/>
+        </p:spPr>
+        <p:txBody>
+          <a:bodyPr wrap="none">
+            <a:spAutoFit/>
+          </a:bodyPr>
+          <a:lstStyle/>
+          <a:p>
+            <a:pPr>
+              <a:defRPr sz="3400" b="1">
+                <a:solidFill>
+                  <a:srgbClr val="22293F"/>
+                </a:solidFill>
+              </a:defRPr>
+            </a:pPr>
+            <a:r>
+              <a:t>管理员端：用户管理</a:t>
+            </a:r>
+          </a:p>
+        </p:txBody>
+      </p:sp>
+      <p:sp>
+        <p:nvSpPr>
+          <p:cNvPr id="5" name="Rounded Rectangle 4"/>
+          <p:cNvSpPr/>
+          <p:nvPr/>
+        </p:nvSpPr>
+        <p:spPr>
+          <a:xfrm>
+            <a:off x="731520" y="1645920"/>
+            <a:ext cx="7498079" cy="4754880"/>
+          </a:xfrm>
+          <a:prstGeom prst="roundRect">
+            <a:avLst/>
+          </a:prstGeom>
+          <a:solidFill>
+            <a:srgbClr val="E8ECF5"/>
+          </a:solidFill>
+          <a:ln>
+            <a:solidFill>
+              <a:srgbClr val="BEC6DC"/>
+            </a:solidFill>
+          </a:ln>
+        </p:spPr>
+        <p:style>
+          <a:lnRef idx="1">
+            <a:schemeClr val="accent1"/>
+          </a:lnRef>
+          <a:fillRef idx="3">
+            <a:schemeClr val="accent1"/>
+          </a:fillRef>
+          <a:effectRef idx="2">
+            <a:schemeClr val="accent1"/>
+          </a:effectRef>
+          <a:fontRef idx="minor">
+            <a:schemeClr val="lt1"/>
+          </a:fontRef>
+        </p:style>
+        <p:txBody>
+          <a:bodyPr rtlCol="0" anchor="ctr"/>
+          <a:lstStyle/>
+          <a:p>
+            <a:pPr algn="ctr">
+              <a:defRPr b="1" sz="1800">
+                <a:solidFill>
+                  <a:srgbClr val="22293F"/>
+                </a:solidFill>
+              </a:defRPr>
+            </a:pPr>
+            <a:r>
+              <a:t>待插入：用户管理</a:t>
+            </a:r>
+          </a:p>
+          <a:p>
+            <a:pPr algn="ctr">
+              <a:defRPr sz="900">
+                <a:solidFill>
+                  <a:srgbClr val="464646"/>
+                </a:solidFill>
+              </a:defRPr>
+            </a:pPr>
+            <a:r>
+              <a:t>https://github.com/user-attachments/assets/a4a8e15f-ff50-4b5b-8f90-be961cac541b</a:t>
+            </a:r>
+          </a:p>
+        </p:txBody>
+      </p:sp>
+      <p:sp>
+        <p:nvSpPr>
+          <p:cNvPr id="6" name="Rounded Rectangle 5"/>
+          <p:cNvSpPr/>
+          <p:nvPr/>
+        </p:nvSpPr>
+        <p:spPr>
+          <a:xfrm>
+            <a:off x="8412480" y="1828800"/>
+            <a:ext cx="2926080" cy="4389120"/>
+          </a:xfrm>
+          <a:prstGeom prst="roundRect">
+            <a:avLst/>
+          </a:prstGeom>
+          <a:solidFill>
+            <a:srgbClr val="FFFFFF"/>
+          </a:solidFill>
+          <a:ln>
+            <a:solidFill>
+              <a:srgbClr val="DCE2F0"/>
+            </a:solidFill>
+          </a:ln>
+        </p:spPr>
+        <p:style>
+          <a:lnRef idx="1">
+            <a:schemeClr val="accent1"/>
+          </a:lnRef>
+          <a:fillRef idx="3">
+            <a:schemeClr val="accent1"/>
+          </a:fillRef>
+          <a:effectRef idx="2">
+            <a:schemeClr val="accent1"/>
+          </a:effectRef>
+          <a:fontRef idx="minor">
+            <a:schemeClr val="lt1"/>
+          </a:fontRef>
+        </p:style>
+        <p:txBody>
+          <a:bodyPr rtlCol="0" anchor="ctr"/>
+          <a:lstStyle/>
+          <a:p>
+            <a:pPr algn="ctr">
+              <a:defRPr sz="2200" b="1">
+                <a:solidFill>
+                  <a:srgbClr val="22293F"/>
+                </a:solidFill>
+              </a:defRPr>
+            </a:pPr>
+            <a:r>
+              <a:t>功能价值</a:t>
+            </a:r>
+          </a:p>
+          <a:p>
+            <a:pPr>
+              <a:defRPr sz="1700">
+                <a:solidFill>
+                  <a:srgbClr val="464646"/>
+                </a:solidFill>
+              </a:defRPr>
+            </a:pPr>
+            <a:r>
+              <a:t>用户信息统一维护</a:t>
+            </a:r>
+          </a:p>
+          <a:p>
+            <a:pPr>
+              <a:defRPr sz="1700">
+                <a:solidFill>
+                  <a:srgbClr val="464646"/>
+                </a:solidFill>
+              </a:defRPr>
+            </a:pPr>
+            <a:r>
+              <a:t>角色权限清晰配置</a:t>
+            </a:r>
+          </a:p>
+          <a:p>
+            <a:pPr>
+              <a:defRPr sz="1700">
+                <a:solidFill>
+                  <a:srgbClr val="464646"/>
+                </a:solidFill>
+              </a:defRPr>
+            </a:pPr>
+            <a:r>
+              <a:t>保障系统稳定运行</a:t>
+            </a:r>
+          </a:p>
+        </p:txBody>
+      </p:sp>
+    </p:spTree>
+  </p:cSld>
+  <p:clrMapOvr>
+    <a:masterClrMapping/>
+  </p:clrMapOvr>
+</p:sld>
+</file>
+
+<file path=ppt/slides/slide14.xml><?xml version="1.0" encoding="utf-8"?>
+<p:sld xmlns:a="http://schemas.openxmlformats.org/drawingml/2006/main" xmlns:p="http://schemas.openxmlformats.org/presentationml/2006/main" xmlns:r="http://schemas.openxmlformats.org/officeDocument/2006/relationships">
+  <p:cSld>
+    <p:spTree>
+      <p:nvGrpSpPr>
+        <p:cNvPr id="1" name=""/>
+        <p:cNvGrpSpPr/>
+        <p:nvPr/>
+      </p:nvGrpSpPr>
+      <p:grpSpPr/>
+      <p:sp>
+        <p:nvSpPr>
+          <p:cNvPr id="2" name="Rectangle 1"/>
+          <p:cNvSpPr/>
+          <p:nvPr/>
+        </p:nvSpPr>
+        <p:spPr>
+          <a:xfrm>
+            <a:off x="0" y="0"/>
+            <a:ext cx="12191695" cy="6858000"/>
+          </a:xfrm>
+          <a:prstGeom prst="rect">
+            <a:avLst/>
+          </a:prstGeom>
+          <a:solidFill>
+            <a:srgbClr val="F6F8FC"/>
+          </a:solidFill>
+          <a:ln>
+            <a:noFill/>
+          </a:ln>
+        </p:spPr>
+        <p:style>
+          <a:lnRef idx="1">
+            <a:schemeClr val="accent1"/>
+          </a:lnRef>
+          <a:fillRef idx="3">
+            <a:schemeClr val="accent1"/>
+          </a:fillRef>
+          <a:effectRef idx="2">
+            <a:schemeClr val="accent1"/>
+          </a:effectRef>
+          <a:fontRef idx="minor">
+            <a:schemeClr val="lt1"/>
+          </a:fontRef>
+        </p:style>
+        <p:txBody>
+          <a:bodyPr rtlCol="0" anchor="ctr"/>
+          <a:lstStyle/>
+          <a:p>
+            <a:pPr algn="ctr"/>
+          </a:p>
+        </p:txBody>
+      </p:sp>
+      <p:sp>
+        <p:nvSpPr>
+          <p:cNvPr id="3" name="Rectangle 2"/>
+          <p:cNvSpPr/>
+          <p:nvPr/>
+        </p:nvSpPr>
+        <p:spPr>
+          <a:xfrm>
+            <a:off x="0" y="0"/>
+            <a:ext cx="12191695" cy="438912"/>
+          </a:xfrm>
+          <a:prstGeom prst="rect">
+            <a:avLst/>
+          </a:prstGeom>
+          <a:solidFill>
+            <a:srgbClr val="22293F"/>
+          </a:solidFill>
+          <a:ln>
+            <a:noFill/>
+          </a:ln>
+        </p:spPr>
+        <p:style>
+          <a:lnRef idx="1">
+            <a:schemeClr val="accent1"/>
+          </a:lnRef>
+          <a:fillRef idx="3">
+            <a:schemeClr val="accent1"/>
+          </a:fillRef>
+          <a:effectRef idx="2">
+            <a:schemeClr val="accent1"/>
+          </a:effectRef>
+          <a:fontRef idx="minor">
+            <a:schemeClr val="lt1"/>
+          </a:fontRef>
+        </p:style>
+        <p:txBody>
+          <a:bodyPr rtlCol="0" anchor="ctr"/>
+          <a:lstStyle/>
+          <a:p>
+            <a:pPr algn="ctr"/>
+          </a:p>
+        </p:txBody>
+      </p:sp>
+      <p:sp>
+        <p:nvSpPr>
+          <p:cNvPr id="4" name="TextBox 3"/>
+          <p:cNvSpPr txBox="1"/>
+          <p:nvPr/>
+        </p:nvSpPr>
+        <p:spPr>
+          <a:xfrm>
+            <a:off x="640080" y="603504"/>
+            <a:ext cx="10972800" cy="914400"/>
+          </a:xfrm>
+          <a:prstGeom prst="rect">
+            <a:avLst/>
+          </a:prstGeom>
+          <a:noFill/>
+        </p:spPr>
+        <p:txBody>
+          <a:bodyPr wrap="none">
+            <a:spAutoFit/>
+          </a:bodyPr>
+          <a:lstStyle/>
+          <a:p>
+            <a:pPr>
+              <a:defRPr sz="3400" b="1">
+                <a:solidFill>
+                  <a:srgbClr val="22293F"/>
+                </a:solidFill>
+              </a:defRPr>
+            </a:pPr>
+            <a:r>
+              <a:t>测试与运行结果</a:t>
+            </a:r>
+          </a:p>
+        </p:txBody>
+      </p:sp>
+      <p:sp>
+        <p:nvSpPr>
+          <p:cNvPr id="5" name="Rounded Rectangle 4"/>
+          <p:cNvSpPr/>
+          <p:nvPr/>
+        </p:nvSpPr>
+        <p:spPr>
+          <a:xfrm>
+            <a:off x="822960" y="1691640"/>
+            <a:ext cx="5303520" cy="4480560"/>
+          </a:xfrm>
+          <a:prstGeom prst="roundRect">
+            <a:avLst/>
+          </a:prstGeom>
+          <a:solidFill>
+            <a:srgbClr val="FFFFFF"/>
+          </a:solidFill>
+          <a:ln>
+            <a:solidFill>
+              <a:srgbClr val="DCE2F0"/>
+            </a:solidFill>
+          </a:ln>
+        </p:spPr>
+        <p:style>
+          <a:lnRef idx="1">
+            <a:schemeClr val="accent1"/>
+          </a:lnRef>
+          <a:fillRef idx="3">
+            <a:schemeClr val="accent1"/>
+          </a:fillRef>
+          <a:effectRef idx="2">
+            <a:schemeClr val="accent1"/>
+          </a:effectRef>
+          <a:fontRef idx="minor">
+            <a:schemeClr val="lt1"/>
+          </a:fontRef>
+        </p:style>
+        <p:txBody>
+          <a:bodyPr rtlCol="0" anchor="ctr"/>
+          <a:lstStyle/>
+          <a:p>
+            <a:pPr algn="ctr">
+              <a:defRPr sz="2200" b="1">
+                <a:solidFill>
+                  <a:srgbClr val="22293F"/>
+                </a:solidFill>
+              </a:defRPr>
+            </a:pPr>
+            <a:r>
+              <a:t>功能验证</a:t>
+            </a:r>
+          </a:p>
+          <a:p>
+            <a:pPr>
+              <a:defRPr sz="1700">
+                <a:solidFill>
+                  <a:srgbClr val="464646"/>
+                </a:solidFill>
+              </a:defRPr>
+            </a:pPr>
+            <a:r>
+              <a:t>登录、课程管理、成绩、考勤、用户管理均可正常运行</a:t>
+            </a:r>
+          </a:p>
+          <a:p>
+            <a:pPr>
+              <a:defRPr sz="1700">
+                <a:solidFill>
+                  <a:srgbClr val="464646"/>
+                </a:solidFill>
+              </a:defRPr>
+            </a:pPr>
+            <a:r>
+              <a:t>核心页面交互链路完整</a:t>
+            </a:r>
+          </a:p>
+        </p:txBody>
+      </p:sp>
+      <p:sp>
+        <p:nvSpPr>
+          <p:cNvPr id="6" name="Rounded Rectangle 5"/>
+          <p:cNvSpPr/>
+          <p:nvPr/>
+        </p:nvSpPr>
+        <p:spPr>
+          <a:xfrm>
+            <a:off x="6035040" y="1691640"/>
+            <a:ext cx="5303520" cy="4480560"/>
+          </a:xfrm>
+          <a:prstGeom prst="roundRect">
+            <a:avLst/>
+          </a:prstGeom>
+          <a:solidFill>
+            <a:srgbClr val="FFFFFF"/>
+          </a:solidFill>
+          <a:ln>
+            <a:solidFill>
+              <a:srgbClr val="DCE2F0"/>
+            </a:solidFill>
+          </a:ln>
+        </p:spPr>
+        <p:style>
+          <a:lnRef idx="1">
+            <a:schemeClr val="accent1"/>
+          </a:lnRef>
+          <a:fillRef idx="3">
+            <a:schemeClr val="accent1"/>
+          </a:fillRef>
+          <a:effectRef idx="2">
+            <a:schemeClr val="accent1"/>
+          </a:effectRef>
+          <a:fontRef idx="minor">
+            <a:schemeClr val="lt1"/>
+          </a:fontRef>
+        </p:style>
+        <p:txBody>
+          <a:bodyPr rtlCol="0" anchor="ctr"/>
+          <a:lstStyle/>
+          <a:p>
+            <a:pPr algn="ctr">
+              <a:defRPr sz="2200" b="1">
+                <a:solidFill>
+                  <a:srgbClr val="22293F"/>
+                </a:solidFill>
+              </a:defRPr>
+            </a:pPr>
+            <a:r>
+              <a:t>质量保障</a:t>
+            </a:r>
+          </a:p>
+          <a:p>
+            <a:pPr>
+              <a:defRPr sz="1700">
+                <a:solidFill>
+                  <a:srgbClr val="464646"/>
+                </a:solidFill>
+              </a:defRPr>
+            </a:pPr>
+            <a:r>
+              <a:t>项目可通过 `mvn -q test` 进行基础验证</a:t>
+            </a:r>
+          </a:p>
+          <a:p>
+            <a:pPr>
+              <a:defRPr sz="1700">
+                <a:solidFill>
+                  <a:srgbClr val="464646"/>
+                </a:solidFill>
+              </a:defRPr>
+            </a:pPr>
+            <a:r>
+              <a:t>页面流程与角色权限符合预期</a:t>
+            </a:r>
+          </a:p>
+        </p:txBody>
+      </p:sp>
+    </p:spTree>
+  </p:cSld>
+  <p:clrMapOvr>
+    <a:masterClrMapping/>
+  </p:clrMapOvr>
+</p:sld>
+</file>
+
+<file path=ppt/slides/slide15.xml><?xml version="1.0" encoding="utf-8"?>
+<p:sld xmlns:a="http://schemas.openxmlformats.org/drawingml/2006/main" xmlns:p="http://schemas.openxmlformats.org/presentationml/2006/main" xmlns:r="http://schemas.openxmlformats.org/officeDocument/2006/relationships">
+  <p:cSld>
+    <p:spTree>
+      <p:nvGrpSpPr>
+        <p:cNvPr id="1" name=""/>
+        <p:cNvGrpSpPr/>
+        <p:nvPr/>
+      </p:nvGrpSpPr>
+      <p:grpSpPr/>
+      <p:sp>
+        <p:nvSpPr>
+          <p:cNvPr id="2" name="Rectangle 1"/>
+          <p:cNvSpPr/>
+          <p:nvPr/>
+        </p:nvSpPr>
+        <p:spPr>
+          <a:xfrm>
+            <a:off x="0" y="0"/>
+            <a:ext cx="12191695" cy="6858000"/>
+          </a:xfrm>
+          <a:prstGeom prst="rect">
+            <a:avLst/>
+          </a:prstGeom>
+          <a:solidFill>
+            <a:srgbClr val="F6F8FC"/>
+          </a:solidFill>
+          <a:ln>
+            <a:noFill/>
+          </a:ln>
+        </p:spPr>
+        <p:style>
+          <a:lnRef idx="1">
+            <a:schemeClr val="accent1"/>
+          </a:lnRef>
+          <a:fillRef idx="3">
+            <a:schemeClr val="accent1"/>
+          </a:fillRef>
+          <a:effectRef idx="2">
+            <a:schemeClr val="accent1"/>
+          </a:effectRef>
+          <a:fontRef idx="minor">
+            <a:schemeClr val="lt1"/>
+          </a:fontRef>
+        </p:style>
+        <p:txBody>
+          <a:bodyPr rtlCol="0" anchor="ctr"/>
+          <a:lstStyle/>
+          <a:p>
+            <a:pPr algn="ctr"/>
+          </a:p>
+        </p:txBody>
+      </p:sp>
+      <p:sp>
+        <p:nvSpPr>
+          <p:cNvPr id="3" name="Rectangle 2"/>
+          <p:cNvSpPr/>
+          <p:nvPr/>
+        </p:nvSpPr>
+        <p:spPr>
+          <a:xfrm>
+            <a:off x="0" y="0"/>
+            <a:ext cx="12191695" cy="438912"/>
+          </a:xfrm>
+          <a:prstGeom prst="rect">
+            <a:avLst/>
+          </a:prstGeom>
+          <a:solidFill>
+            <a:srgbClr val="22293F"/>
+          </a:solidFill>
+          <a:ln>
+            <a:noFill/>
+          </a:ln>
+        </p:spPr>
+        <p:style>
+          <a:lnRef idx="1">
+            <a:schemeClr val="accent1"/>
+          </a:lnRef>
+          <a:fillRef idx="3">
+            <a:schemeClr val="accent1"/>
+          </a:fillRef>
+          <a:effectRef idx="2">
+            <a:schemeClr val="accent1"/>
+          </a:effectRef>
+          <a:fontRef idx="minor">
+            <a:schemeClr val="lt1"/>
+          </a:fontRef>
+        </p:style>
+        <p:txBody>
+          <a:bodyPr rtlCol="0" anchor="ctr"/>
+          <a:lstStyle/>
+          <a:p>
+            <a:pPr algn="ctr"/>
+          </a:p>
+        </p:txBody>
+      </p:sp>
+      <p:sp>
+        <p:nvSpPr>
+          <p:cNvPr id="4" name="Rounded Rectangle 3"/>
+          <p:cNvSpPr/>
+          <p:nvPr/>
+        </p:nvSpPr>
+        <p:spPr>
+          <a:xfrm>
+            <a:off x="914400" y="1097280"/>
+            <a:ext cx="10332720" cy="4754880"/>
+          </a:xfrm>
+          <a:prstGeom prst="roundRect">
+            <a:avLst/>
+          </a:prstGeom>
+          <a:solidFill>
+            <a:srgbClr val="FFFFFF"/>
+          </a:solidFill>
+          <a:ln>
+            <a:solidFill>
+              <a:srgbClr val="DCE2F0"/>
+            </a:solidFill>
+          </a:ln>
+        </p:spPr>
+        <p:style>
+          <a:lnRef idx="1">
+            <a:schemeClr val="accent1"/>
+          </a:lnRef>
+          <a:fillRef idx="3">
+            <a:schemeClr val="accent1"/>
+          </a:fillRef>
+          <a:effectRef idx="2">
+            <a:schemeClr val="accent1"/>
+          </a:effectRef>
+          <a:fontRef idx="minor">
+            <a:schemeClr val="lt1"/>
+          </a:fontRef>
+        </p:style>
+        <p:txBody>
+          <a:bodyPr rtlCol="0" anchor="ctr"/>
+          <a:lstStyle/>
+          <a:p>
+            <a:pPr algn="ctr">
+              <a:defRPr sz="3600" b="1">
+                <a:solidFill>
+                  <a:srgbClr val="22293F"/>
                 </a:solidFill>
               </a:defRPr>
             </a:pPr>
@@ -3421,36 +4769,36 @@
             <a:pPr algn="ctr">
               <a:defRPr sz="2200">
                 <a:solidFill>
-                  <a:srgbClr val="373737"/>
-                </a:solidFill>
-              </a:defRPr>
-            </a:pPr>
-            <a:r>
-              <a:t>已完成多角色核心业务能力搭建，具备实际应用价值</a:t>
+                  <a:srgbClr val="464646"/>
+                </a:solidFill>
+              </a:defRPr>
+            </a:pPr>
+            <a:r>
+              <a:t>已实现多角色一体化课程活动管理能力</a:t>
             </a:r>
           </a:p>
           <a:p>
             <a:pPr algn="ctr">
               <a:defRPr sz="2000">
                 <a:solidFill>
-                  <a:srgbClr val="373737"/>
-                </a:solidFill>
-              </a:defRPr>
-            </a:pPr>
-            <a:r>
-              <a:t>后续可扩展：数据可视化分析、移动端适配、智能推荐</a:t>
+                  <a:srgbClr val="464646"/>
+                </a:solidFill>
+              </a:defRPr>
+            </a:pPr>
+            <a:r>
+              <a:t>后续可扩展：数据可视化、移动端适配、智能推荐</a:t>
             </a:r>
           </a:p>
           <a:p>
             <a:pPr algn="ctr">
-              <a:defRPr b="1" sz="3000">
-                <a:solidFill>
-                  <a:srgbClr val="2850A0"/>
-                </a:solidFill>
-              </a:defRPr>
-            </a:pPr>
-            <a:r>
-              <a:t>感谢各位老师！</a:t>
+              <a:defRPr sz="3000" b="1">
+                <a:solidFill>
+                  <a:srgbClr val="3166BE"/>
+                </a:solidFill>
+              </a:defRPr>
+            </a:pPr>
+            <a:r>
+              <a:t>感谢各位老师指正！</a:t>
             </a:r>
           </a:p>
         </p:txBody>
@@ -3525,13 +4873,13 @@
         <p:spPr>
           <a:xfrm>
             <a:off x="0" y="0"/>
-            <a:ext cx="12191695" cy="502920"/>
+            <a:ext cx="12191695" cy="438912"/>
           </a:xfrm>
           <a:prstGeom prst="rect">
             <a:avLst/>
           </a:prstGeom>
           <a:solidFill>
-            <a:srgbClr val="20253A"/>
+            <a:srgbClr val="22293F"/>
           </a:solidFill>
           <a:ln>
             <a:noFill/>
@@ -3567,8 +4915,8 @@
         </p:nvSpPr>
         <p:spPr>
           <a:xfrm>
-            <a:off x="640080" y="658368"/>
-            <a:ext cx="10972800" cy="731520"/>
+            <a:off x="640080" y="603504"/>
+            <a:ext cx="10972800" cy="914400"/>
           </a:xfrm>
           <a:prstGeom prst="rect">
             <a:avLst/>
@@ -3584,7 +4932,7 @@
             <a:pPr>
               <a:defRPr sz="3400" b="1">
                 <a:solidFill>
-                  <a:srgbClr val="20253A"/>
+                  <a:srgbClr val="22293F"/>
                 </a:solidFill>
               </a:defRPr>
             </a:pPr>
@@ -3596,12 +4944,12 @@
             <a:pPr>
               <a:defRPr sz="1500">
                 <a:solidFill>
-                  <a:srgbClr val="373737"/>
-                </a:solidFill>
-              </a:defRPr>
-            </a:pPr>
-            <a:r>
-              <a:t>简洁展示系统设计与核心功能</a:t>
+                  <a:srgbClr val="464646"/>
+                </a:solidFill>
+              </a:defRPr>
+            </a:pPr>
+            <a:r>
+              <a:t>全流程展示系统能力</a:t>
             </a:r>
           </a:p>
         </p:txBody>
@@ -3614,8 +4962,8 @@
         </p:nvSpPr>
         <p:spPr>
           <a:xfrm>
-            <a:off x="1097280" y="1645920"/>
-            <a:ext cx="9966960" cy="4480560"/>
+            <a:off x="1097280" y="1737360"/>
+            <a:ext cx="9875520" cy="4389120"/>
           </a:xfrm>
           <a:prstGeom prst="roundRect">
             <a:avLst/>
@@ -3648,77 +4996,74 @@
           <a:lstStyle/>
           <a:p>
             <a:pPr algn="ctr">
-              <a:spcAft>
-                <a:spcPts val="1000"/>
-              </a:spcAft>
-              <a:defRPr sz="2000" b="1">
-                <a:solidFill>
-                  <a:srgbClr val="20253A"/>
-                </a:solidFill>
-              </a:defRPr>
-            </a:pPr>
-            <a:r>
-              <a:t>01  项目背景与目标</a:t>
+              <a:defRPr sz="2200" b="1">
+                <a:solidFill>
+                  <a:srgbClr val="22293F"/>
+                </a:solidFill>
+              </a:defRPr>
+            </a:pPr>
+            <a:r>
+              <a:t>章节安排</a:t>
             </a:r>
           </a:p>
           <a:p>
             <a:pPr>
-              <a:spcAft>
-                <a:spcPts val="1000"/>
-              </a:spcAft>
-              <a:defRPr sz="1800" b="0">
-                <a:solidFill>
-                  <a:srgbClr val="373737"/>
-                </a:solidFill>
-              </a:defRPr>
-            </a:pPr>
-            <a:r>
-              <a:t>02  系统总体设计</a:t>
+              <a:defRPr sz="1700">
+                <a:solidFill>
+                  <a:srgbClr val="464646"/>
+                </a:solidFill>
+              </a:defRPr>
+            </a:pPr>
+            <a:r>
+              <a:t>1. 项目背景与目标</a:t>
             </a:r>
           </a:p>
           <a:p>
             <a:pPr>
-              <a:spcAft>
-                <a:spcPts val="1000"/>
-              </a:spcAft>
-              <a:defRPr sz="1800" b="0">
-                <a:solidFill>
-                  <a:srgbClr val="373737"/>
-                </a:solidFill>
-              </a:defRPr>
-            </a:pPr>
-            <a:r>
-              <a:t>03  核心功能演示</a:t>
+              <a:defRPr sz="1700">
+                <a:solidFill>
+                  <a:srgbClr val="464646"/>
+                </a:solidFill>
+              </a:defRPr>
+            </a:pPr>
+            <a:r>
+              <a:t>2. 需求分析与角色职责</a:t>
             </a:r>
           </a:p>
           <a:p>
             <a:pPr>
-              <a:spcAft>
-                <a:spcPts val="1000"/>
-              </a:spcAft>
-              <a:defRPr sz="1800" b="0">
-                <a:solidFill>
-                  <a:srgbClr val="373737"/>
-                </a:solidFill>
-              </a:defRPr>
-            </a:pPr>
-            <a:r>
-              <a:t>04  技术实现与亮点</a:t>
+              <a:defRPr sz="1700">
+                <a:solidFill>
+                  <a:srgbClr val="464646"/>
+                </a:solidFill>
+              </a:defRPr>
+            </a:pPr>
+            <a:r>
+              <a:t>3. 系统架构与数据库设计</a:t>
             </a:r>
           </a:p>
           <a:p>
             <a:pPr>
-              <a:spcAft>
-                <a:spcPts val="1000"/>
-              </a:spcAft>
-              <a:defRPr sz="1800" b="0">
-                <a:solidFill>
-                  <a:srgbClr val="373737"/>
-                </a:solidFill>
-              </a:defRPr>
-            </a:pPr>
-            <a:r>
-              <a:t>05  总结与展望</a:t>
+              <a:defRPr sz="1700">
+                <a:solidFill>
+                  <a:srgbClr val="464646"/>
+                </a:solidFill>
+              </a:defRPr>
+            </a:pPr>
+            <a:r>
+              <a:t>4. 关键功能演示（教师/管理员）</a:t>
+            </a:r>
+          </a:p>
+          <a:p>
+            <a:pPr>
+              <a:defRPr sz="1700">
+                <a:solidFill>
+                  <a:srgbClr val="464646"/>
+                </a:solidFill>
+              </a:defRPr>
+            </a:pPr>
+            <a:r>
+              <a:t>5. 测试结果与总结展望</a:t>
             </a:r>
           </a:p>
         </p:txBody>
@@ -3793,13 +5138,13 @@
         <p:spPr>
           <a:xfrm>
             <a:off x="0" y="0"/>
-            <a:ext cx="12191695" cy="502920"/>
+            <a:ext cx="12191695" cy="438912"/>
           </a:xfrm>
           <a:prstGeom prst="rect">
             <a:avLst/>
           </a:prstGeom>
           <a:solidFill>
-            <a:srgbClr val="20253A"/>
+            <a:srgbClr val="22293F"/>
           </a:solidFill>
           <a:ln>
             <a:noFill/>
@@ -3835,8 +5180,8 @@
         </p:nvSpPr>
         <p:spPr>
           <a:xfrm>
-            <a:off x="640080" y="658368"/>
-            <a:ext cx="10972800" cy="731520"/>
+            <a:off x="640080" y="603504"/>
+            <a:ext cx="10972800" cy="914400"/>
           </a:xfrm>
           <a:prstGeom prst="rect">
             <a:avLst/>
@@ -3852,7 +5197,7 @@
             <a:pPr>
               <a:defRPr sz="3400" b="1">
                 <a:solidFill>
-                  <a:srgbClr val="20253A"/>
+                  <a:srgbClr val="22293F"/>
                 </a:solidFill>
               </a:defRPr>
             </a:pPr>
@@ -3870,7 +5215,7 @@
         </p:nvSpPr>
         <p:spPr>
           <a:xfrm>
-            <a:off x="822960" y="1645920"/>
+            <a:off x="822960" y="1691640"/>
             <a:ext cx="5303520" cy="4480560"/>
           </a:xfrm>
           <a:prstGeom prst="roundRect">
@@ -3904,62 +5249,38 @@
           <a:lstStyle/>
           <a:p>
             <a:pPr algn="ctr">
-              <a:spcAft>
-                <a:spcPts val="1000"/>
-              </a:spcAft>
-              <a:defRPr sz="2000" b="1">
-                <a:solidFill>
-                  <a:srgbClr val="20253A"/>
-                </a:solidFill>
-              </a:defRPr>
-            </a:pPr>
-            <a:r>
-              <a:t>建设目标</a:t>
+              <a:defRPr sz="2200" b="1">
+                <a:solidFill>
+                  <a:srgbClr val="22293F"/>
+                </a:solidFill>
+              </a:defRPr>
+            </a:pPr>
+            <a:r>
+              <a:t>建设背景</a:t>
             </a:r>
           </a:p>
           <a:p>
             <a:pPr>
-              <a:spcAft>
-                <a:spcPts val="1000"/>
-              </a:spcAft>
-              <a:defRPr sz="1800" b="0">
-                <a:solidFill>
-                  <a:srgbClr val="373737"/>
-                </a:solidFill>
-              </a:defRPr>
-            </a:pPr>
-            <a:r>
-              <a:t>面向学生、教师、管理员的统一活动管理平台</a:t>
+              <a:defRPr sz="1700">
+                <a:solidFill>
+                  <a:srgbClr val="464646"/>
+                </a:solidFill>
+              </a:defRPr>
+            </a:pPr>
+            <a:r>
+              <a:t>传统线下管理效率低、信息不透明</a:t>
             </a:r>
           </a:p>
           <a:p>
             <a:pPr>
-              <a:spcAft>
-                <a:spcPts val="1000"/>
-              </a:spcAft>
-              <a:defRPr sz="1800" b="0">
-                <a:solidFill>
-                  <a:srgbClr val="373737"/>
-                </a:solidFill>
-              </a:defRPr>
-            </a:pPr>
-            <a:r>
-              <a:t>解决报名、管理、考勤、成绩、评价的全流程数字化</a:t>
-            </a:r>
-          </a:p>
-          <a:p>
-            <a:pPr>
-              <a:spcAft>
-                <a:spcPts val="1000"/>
-              </a:spcAft>
-              <a:defRPr sz="1800" b="0">
-                <a:solidFill>
-                  <a:srgbClr val="373737"/>
-                </a:solidFill>
-              </a:defRPr>
-            </a:pPr>
-            <a:r>
-              <a:t>提升信息透明度与管理效率</a:t>
+              <a:defRPr sz="1700">
+                <a:solidFill>
+                  <a:srgbClr val="464646"/>
+                </a:solidFill>
+              </a:defRPr>
+            </a:pPr>
+            <a:r>
+              <a:t>缺少统一平台协同学生/教师/管理员</a:t>
             </a:r>
           </a:p>
         </p:txBody>
@@ -3972,7 +5293,7 @@
         </p:nvSpPr>
         <p:spPr>
           <a:xfrm>
-            <a:off x="6035040" y="1645920"/>
+            <a:off x="6035040" y="1691640"/>
             <a:ext cx="5303520" cy="4480560"/>
           </a:xfrm>
           <a:prstGeom prst="roundRect">
@@ -4006,62 +5327,50 @@
           <a:lstStyle/>
           <a:p>
             <a:pPr algn="ctr">
-              <a:spcAft>
-                <a:spcPts val="1000"/>
-              </a:spcAft>
-              <a:defRPr sz="2000" b="1">
-                <a:solidFill>
-                  <a:srgbClr val="20253A"/>
-                </a:solidFill>
-              </a:defRPr>
-            </a:pPr>
-            <a:r>
-              <a:t>角色职责</a:t>
+              <a:defRPr sz="2200" b="1">
+                <a:solidFill>
+                  <a:srgbClr val="22293F"/>
+                </a:solidFill>
+              </a:defRPr>
+            </a:pPr>
+            <a:r>
+              <a:t>项目目标</a:t>
             </a:r>
           </a:p>
           <a:p>
             <a:pPr>
-              <a:spcAft>
-                <a:spcPts val="1000"/>
-              </a:spcAft>
-              <a:defRPr sz="1800" b="0">
-                <a:solidFill>
-                  <a:srgbClr val="373737"/>
-                </a:solidFill>
-              </a:defRPr>
-            </a:pPr>
-            <a:r>
-              <a:t>学生：报名课程/活动、参与评价</a:t>
+              <a:defRPr sz="1700">
+                <a:solidFill>
+                  <a:srgbClr val="464646"/>
+                </a:solidFill>
+              </a:defRPr>
+            </a:pPr>
+            <a:r>
+              <a:t>课程活动全流程数字化</a:t>
             </a:r>
           </a:p>
           <a:p>
             <a:pPr>
-              <a:spcAft>
-                <a:spcPts val="1000"/>
-              </a:spcAft>
-              <a:defRPr sz="1800" b="0">
-                <a:solidFill>
-                  <a:srgbClr val="373737"/>
-                </a:solidFill>
-              </a:defRPr>
-            </a:pPr>
-            <a:r>
-              <a:t>教师：课程管理、成绩录入、考勤管理</a:t>
+              <a:defRPr sz="1700">
+                <a:solidFill>
+                  <a:srgbClr val="464646"/>
+                </a:solidFill>
+              </a:defRPr>
+            </a:pPr>
+            <a:r>
+              <a:t>提升管理效率与体验</a:t>
             </a:r>
           </a:p>
           <a:p>
             <a:pPr>
-              <a:spcAft>
-                <a:spcPts val="1000"/>
-              </a:spcAft>
-              <a:defRPr sz="1800" b="0">
-                <a:solidFill>
-                  <a:srgbClr val="373737"/>
-                </a:solidFill>
-              </a:defRPr>
-            </a:pPr>
-            <a:r>
-              <a:t>管理员：用户管理与系统维护</a:t>
+              <a:defRPr sz="1700">
+                <a:solidFill>
+                  <a:srgbClr val="464646"/>
+                </a:solidFill>
+              </a:defRPr>
+            </a:pPr>
+            <a:r>
+              <a:t>形成可扩展的教学活动管理系统</a:t>
             </a:r>
           </a:p>
         </p:txBody>
@@ -4136,13 +5445,13 @@
         <p:spPr>
           <a:xfrm>
             <a:off x="0" y="0"/>
-            <a:ext cx="12191695" cy="502920"/>
+            <a:ext cx="12191695" cy="438912"/>
           </a:xfrm>
           <a:prstGeom prst="rect">
             <a:avLst/>
           </a:prstGeom>
           <a:solidFill>
-            <a:srgbClr val="20253A"/>
+            <a:srgbClr val="22293F"/>
           </a:solidFill>
           <a:ln>
             <a:noFill/>
@@ -4178,8 +5487,8 @@
         </p:nvSpPr>
         <p:spPr>
           <a:xfrm>
-            <a:off x="640080" y="658368"/>
-            <a:ext cx="10972800" cy="731520"/>
+            <a:off x="640080" y="603504"/>
+            <a:ext cx="10972800" cy="914400"/>
           </a:xfrm>
           <a:prstGeom prst="rect">
             <a:avLst/>
@@ -4195,24 +5504,12 @@
             <a:pPr>
               <a:defRPr sz="3400" b="1">
                 <a:solidFill>
-                  <a:srgbClr val="20253A"/>
-                </a:solidFill>
-              </a:defRPr>
-            </a:pPr>
-            <a:r>
-              <a:t>系统总体设计（数据库）</a:t>
-            </a:r>
-          </a:p>
-          <a:p>
-            <a:pPr>
-              <a:defRPr sz="1500">
-                <a:solidFill>
-                  <a:srgbClr val="373737"/>
-                </a:solidFill>
-              </a:defRPr>
-            </a:pPr>
-            <a:r>
-              <a:t>以数据模型支撑业务闭环</a:t>
+                  <a:srgbClr val="22293F"/>
+                </a:solidFill>
+              </a:defRPr>
+            </a:pPr>
+            <a:r>
+              <a:t>角色与业务边界</a:t>
             </a:r>
           </a:p>
         </p:txBody>
@@ -4225,18 +5522,18 @@
         </p:nvSpPr>
         <p:spPr>
           <a:xfrm>
-            <a:off x="731520" y="1600200"/>
-            <a:ext cx="10789920" cy="4892040"/>
+            <a:off x="822960" y="1691640"/>
+            <a:ext cx="3566160" cy="4480560"/>
           </a:xfrm>
           <a:prstGeom prst="roundRect">
             <a:avLst/>
           </a:prstGeom>
           <a:solidFill>
-            <a:srgbClr val="E8ECF5"/>
+            <a:srgbClr val="FFFFFF"/>
           </a:solidFill>
           <a:ln>
             <a:solidFill>
-              <a:srgbClr val="BEC6DC"/>
+              <a:srgbClr val="DCE2F0"/>
             </a:solidFill>
           </a:ln>
         </p:spPr>
@@ -4259,26 +5556,230 @@
           <a:lstStyle/>
           <a:p>
             <a:pPr algn="ctr">
-              <a:defRPr b="1" sz="2000">
-                <a:solidFill>
-                  <a:srgbClr val="20253A"/>
-                </a:solidFill>
-              </a:defRPr>
-            </a:pPr>
-            <a:r>
-              <a:t>待插入截图：数据库总体设计图</a:t>
-            </a:r>
-          </a:p>
+              <a:defRPr sz="2200" b="1">
+                <a:solidFill>
+                  <a:srgbClr val="22293F"/>
+                </a:solidFill>
+              </a:defRPr>
+            </a:pPr>
+            <a:r>
+              <a:t>学生端</a:t>
+            </a:r>
+          </a:p>
+          <a:p>
+            <a:pPr>
+              <a:defRPr sz="1700">
+                <a:solidFill>
+                  <a:srgbClr val="464646"/>
+                </a:solidFill>
+              </a:defRPr>
+            </a:pPr>
+            <a:r>
+              <a:t>浏览课程活动</a:t>
+            </a:r>
+          </a:p>
+          <a:p>
+            <a:pPr>
+              <a:defRPr sz="1700">
+                <a:solidFill>
+                  <a:srgbClr val="464646"/>
+                </a:solidFill>
+              </a:defRPr>
+            </a:pPr>
+            <a:r>
+              <a:t>报名参与</a:t>
+            </a:r>
+          </a:p>
+          <a:p>
+            <a:pPr>
+              <a:defRPr sz="1700">
+                <a:solidFill>
+                  <a:srgbClr val="464646"/>
+                </a:solidFill>
+              </a:defRPr>
+            </a:pPr>
+            <a:r>
+              <a:t>查看结果并评价</a:t>
+            </a:r>
+          </a:p>
+        </p:txBody>
+      </p:sp>
+      <p:sp>
+        <p:nvSpPr>
+          <p:cNvPr id="6" name="Rounded Rectangle 5"/>
+          <p:cNvSpPr/>
+          <p:nvPr/>
+        </p:nvSpPr>
+        <p:spPr>
+          <a:xfrm>
+            <a:off x="4526280" y="1691640"/>
+            <a:ext cx="3566160" cy="4480560"/>
+          </a:xfrm>
+          <a:prstGeom prst="roundRect">
+            <a:avLst/>
+          </a:prstGeom>
+          <a:solidFill>
+            <a:srgbClr val="FFFFFF"/>
+          </a:solidFill>
+          <a:ln>
+            <a:solidFill>
+              <a:srgbClr val="DCE2F0"/>
+            </a:solidFill>
+          </a:ln>
+        </p:spPr>
+        <p:style>
+          <a:lnRef idx="1">
+            <a:schemeClr val="accent1"/>
+          </a:lnRef>
+          <a:fillRef idx="3">
+            <a:schemeClr val="accent1"/>
+          </a:fillRef>
+          <a:effectRef idx="2">
+            <a:schemeClr val="accent1"/>
+          </a:effectRef>
+          <a:fontRef idx="minor">
+            <a:schemeClr val="lt1"/>
+          </a:fontRef>
+        </p:style>
+        <p:txBody>
+          <a:bodyPr rtlCol="0" anchor="ctr"/>
+          <a:lstStyle/>
           <a:p>
             <a:pPr algn="ctr">
-              <a:defRPr sz="1000">
-                <a:solidFill>
-                  <a:srgbClr val="5A5A5A"/>
-                </a:solidFill>
-              </a:defRPr>
-            </a:pPr>
-            <a:r>
-              <a:t>https://github.com/user-attachments/assets/ef132e26-312f-4b6f-a9c5-8fe7e091f630</a:t>
+              <a:defRPr sz="2200" b="1">
+                <a:solidFill>
+                  <a:srgbClr val="22293F"/>
+                </a:solidFill>
+              </a:defRPr>
+            </a:pPr>
+            <a:r>
+              <a:t>教师端</a:t>
+            </a:r>
+          </a:p>
+          <a:p>
+            <a:pPr>
+              <a:defRPr sz="1700">
+                <a:solidFill>
+                  <a:srgbClr val="464646"/>
+                </a:solidFill>
+              </a:defRPr>
+            </a:pPr>
+            <a:r>
+              <a:t>课程/活动维护</a:t>
+            </a:r>
+          </a:p>
+          <a:p>
+            <a:pPr>
+              <a:defRPr sz="1700">
+                <a:solidFill>
+                  <a:srgbClr val="464646"/>
+                </a:solidFill>
+              </a:defRPr>
+            </a:pPr>
+            <a:r>
+              <a:t>成绩录入</a:t>
+            </a:r>
+          </a:p>
+          <a:p>
+            <a:pPr>
+              <a:defRPr sz="1700">
+                <a:solidFill>
+                  <a:srgbClr val="464646"/>
+                </a:solidFill>
+              </a:defRPr>
+            </a:pPr>
+            <a:r>
+              <a:t>考勤管理</a:t>
+            </a:r>
+          </a:p>
+        </p:txBody>
+      </p:sp>
+      <p:sp>
+        <p:nvSpPr>
+          <p:cNvPr id="7" name="Rounded Rectangle 6"/>
+          <p:cNvSpPr/>
+          <p:nvPr/>
+        </p:nvSpPr>
+        <p:spPr>
+          <a:xfrm>
+            <a:off x="8229600" y="1691640"/>
+            <a:ext cx="3108960" cy="4480560"/>
+          </a:xfrm>
+          <a:prstGeom prst="roundRect">
+            <a:avLst/>
+          </a:prstGeom>
+          <a:solidFill>
+            <a:srgbClr val="FFFFFF"/>
+          </a:solidFill>
+          <a:ln>
+            <a:solidFill>
+              <a:srgbClr val="DCE2F0"/>
+            </a:solidFill>
+          </a:ln>
+        </p:spPr>
+        <p:style>
+          <a:lnRef idx="1">
+            <a:schemeClr val="accent1"/>
+          </a:lnRef>
+          <a:fillRef idx="3">
+            <a:schemeClr val="accent1"/>
+          </a:fillRef>
+          <a:effectRef idx="2">
+            <a:schemeClr val="accent1"/>
+          </a:effectRef>
+          <a:fontRef idx="minor">
+            <a:schemeClr val="lt1"/>
+          </a:fontRef>
+        </p:style>
+        <p:txBody>
+          <a:bodyPr rtlCol="0" anchor="ctr"/>
+          <a:lstStyle/>
+          <a:p>
+            <a:pPr algn="ctr">
+              <a:defRPr sz="2200" b="1">
+                <a:solidFill>
+                  <a:srgbClr val="22293F"/>
+                </a:solidFill>
+              </a:defRPr>
+            </a:pPr>
+            <a:r>
+              <a:t>管理员端</a:t>
+            </a:r>
+          </a:p>
+          <a:p>
+            <a:pPr>
+              <a:defRPr sz="1700">
+                <a:solidFill>
+                  <a:srgbClr val="464646"/>
+                </a:solidFill>
+              </a:defRPr>
+            </a:pPr>
+            <a:r>
+              <a:t>用户管理</a:t>
+            </a:r>
+          </a:p>
+          <a:p>
+            <a:pPr>
+              <a:defRPr sz="1700">
+                <a:solidFill>
+                  <a:srgbClr val="464646"/>
+                </a:solidFill>
+              </a:defRPr>
+            </a:pPr>
+            <a:r>
+              <a:t>角色权限维护</a:t>
+            </a:r>
+          </a:p>
+          <a:p>
+            <a:pPr>
+              <a:defRPr sz="1700">
+                <a:solidFill>
+                  <a:srgbClr val="464646"/>
+                </a:solidFill>
+              </a:defRPr>
+            </a:pPr>
+            <a:r>
+              <a:t>数据基础维护</a:t>
             </a:r>
           </a:p>
         </p:txBody>
@@ -4353,13 +5854,13 @@
         <p:spPr>
           <a:xfrm>
             <a:off x="0" y="0"/>
-            <a:ext cx="12191695" cy="502920"/>
+            <a:ext cx="12191695" cy="438912"/>
           </a:xfrm>
           <a:prstGeom prst="rect">
             <a:avLst/>
           </a:prstGeom>
           <a:solidFill>
-            <a:srgbClr val="20253A"/>
+            <a:srgbClr val="22293F"/>
           </a:solidFill>
           <a:ln>
             <a:noFill/>
@@ -4395,8 +5896,8 @@
         </p:nvSpPr>
         <p:spPr>
           <a:xfrm>
-            <a:off x="640080" y="658368"/>
-            <a:ext cx="10972800" cy="731520"/>
+            <a:off x="640080" y="603504"/>
+            <a:ext cx="10972800" cy="914400"/>
           </a:xfrm>
           <a:prstGeom prst="rect">
             <a:avLst/>
@@ -4412,24 +5913,12 @@
             <a:pPr>
               <a:defRPr sz="3400" b="1">
                 <a:solidFill>
-                  <a:srgbClr val="20253A"/>
-                </a:solidFill>
-              </a:defRPr>
-            </a:pPr>
-            <a:r>
-              <a:t>登录与角色入口</a:t>
-            </a:r>
-          </a:p>
-          <a:p>
-            <a:pPr>
-              <a:defRPr sz="1500">
-                <a:solidFill>
-                  <a:srgbClr val="373737"/>
-                </a:solidFill>
-              </a:defRPr>
-            </a:pPr>
-            <a:r>
-              <a:t>统一认证，按角色进入对应功能域</a:t>
+                  <a:srgbClr val="22293F"/>
+                </a:solidFill>
+              </a:defRPr>
+            </a:pPr>
+            <a:r>
+              <a:t>系统技术架构</a:t>
             </a:r>
           </a:p>
         </p:txBody>
@@ -4442,18 +5931,18 @@
         </p:nvSpPr>
         <p:spPr>
           <a:xfrm>
-            <a:off x="777240" y="1645920"/>
-            <a:ext cx="7315200" cy="4754880"/>
+            <a:off x="822960" y="1691640"/>
+            <a:ext cx="5303520" cy="4480560"/>
           </a:xfrm>
           <a:prstGeom prst="roundRect">
             <a:avLst/>
           </a:prstGeom>
           <a:solidFill>
-            <a:srgbClr val="E8ECF5"/>
+            <a:srgbClr val="FFFFFF"/>
           </a:solidFill>
           <a:ln>
             <a:solidFill>
-              <a:srgbClr val="BEC6DC"/>
+              <a:srgbClr val="DCE2F0"/>
             </a:solidFill>
           </a:ln>
         </p:spPr>
@@ -4476,26 +5965,50 @@
           <a:lstStyle/>
           <a:p>
             <a:pPr algn="ctr">
-              <a:defRPr b="1" sz="2000">
-                <a:solidFill>
-                  <a:srgbClr val="20253A"/>
-                </a:solidFill>
-              </a:defRPr>
-            </a:pPr>
-            <a:r>
-              <a:t>待插入截图：登录页面</a:t>
-            </a:r>
-          </a:p>
-          <a:p>
-            <a:pPr algn="ctr">
-              <a:defRPr sz="1000">
-                <a:solidFill>
-                  <a:srgbClr val="5A5A5A"/>
-                </a:solidFill>
-              </a:defRPr>
-            </a:pPr>
-            <a:r>
-              <a:t>https://github.com/user-attachments/assets/d5695ebd-ffb9-4766-93e6-bef8c12eaf6c</a:t>
+              <a:defRPr sz="2200" b="1">
+                <a:solidFill>
+                  <a:srgbClr val="22293F"/>
+                </a:solidFill>
+              </a:defRPr>
+            </a:pPr>
+            <a:r>
+              <a:t>技术栈</a:t>
+            </a:r>
+          </a:p>
+          <a:p>
+            <a:pPr>
+              <a:defRPr sz="1700">
+                <a:solidFill>
+                  <a:srgbClr val="464646"/>
+                </a:solidFill>
+              </a:defRPr>
+            </a:pPr>
+            <a:r>
+              <a:t>后端：Spring + Spring MVC + MyBatis</a:t>
+            </a:r>
+          </a:p>
+          <a:p>
+            <a:pPr>
+              <a:defRPr sz="1700">
+                <a:solidFill>
+                  <a:srgbClr val="464646"/>
+                </a:solidFill>
+              </a:defRPr>
+            </a:pPr>
+            <a:r>
+              <a:t>前端：JSP + Bootstrap/AdminLTE</a:t>
+            </a:r>
+          </a:p>
+          <a:p>
+            <a:pPr>
+              <a:defRPr sz="1700">
+                <a:solidFill>
+                  <a:srgbClr val="464646"/>
+                </a:solidFill>
+              </a:defRPr>
+            </a:pPr>
+            <a:r>
+              <a:t>数据库：MySQL</a:t>
             </a:r>
           </a:p>
         </p:txBody>
@@ -4508,8 +6021,8 @@
         </p:nvSpPr>
         <p:spPr>
           <a:xfrm>
-            <a:off x="8229600" y="1783080"/>
-            <a:ext cx="3474720" cy="4480560"/>
+            <a:off x="6035040" y="1691640"/>
+            <a:ext cx="5303520" cy="4480560"/>
           </a:xfrm>
           <a:prstGeom prst="roundRect">
             <a:avLst/>
@@ -4542,12 +6055,9 @@
           <a:lstStyle/>
           <a:p>
             <a:pPr algn="ctr">
-              <a:spcAft>
-                <a:spcPts val="1000"/>
-              </a:spcAft>
-              <a:defRPr sz="2000" b="1">
-                <a:solidFill>
-                  <a:srgbClr val="20253A"/>
+              <a:defRPr sz="2200" b="1">
+                <a:solidFill>
+                  <a:srgbClr val="22293F"/>
                 </a:solidFill>
               </a:defRPr>
             </a:pPr>
@@ -4557,47 +6067,38 @@
           </a:p>
           <a:p>
             <a:pPr>
-              <a:spcAft>
-                <a:spcPts val="1000"/>
-              </a:spcAft>
-              <a:defRPr sz="1800" b="0">
-                <a:solidFill>
-                  <a:srgbClr val="373737"/>
-                </a:solidFill>
-              </a:defRPr>
-            </a:pPr>
-            <a:r>
-              <a:t>账号密码 + 验证码校验</a:t>
+              <a:defRPr sz="1700">
+                <a:solidFill>
+                  <a:srgbClr val="464646"/>
+                </a:solidFill>
+              </a:defRPr>
+            </a:pPr>
+            <a:r>
+              <a:t>分层结构清晰：Controller/Service/DAO</a:t>
             </a:r>
           </a:p>
           <a:p>
             <a:pPr>
-              <a:spcAft>
-                <a:spcPts val="1000"/>
-              </a:spcAft>
-              <a:defRPr sz="1800" b="0">
-                <a:solidFill>
-                  <a:srgbClr val="373737"/>
-                </a:solidFill>
-              </a:defRPr>
-            </a:pPr>
-            <a:r>
-              <a:t>学生 / 教师 / 管理员多角色切换</a:t>
+              <a:defRPr sz="1700">
+                <a:solidFill>
+                  <a:srgbClr val="464646"/>
+                </a:solidFill>
+              </a:defRPr>
+            </a:pPr>
+            <a:r>
+              <a:t>角色权限控制保障访问安全</a:t>
             </a:r>
           </a:p>
           <a:p>
             <a:pPr>
-              <a:spcAft>
-                <a:spcPts val="1000"/>
-              </a:spcAft>
-              <a:defRPr sz="1800" b="0">
-                <a:solidFill>
-                  <a:srgbClr val="373737"/>
-                </a:solidFill>
-              </a:defRPr>
-            </a:pPr>
-            <a:r>
-              <a:t>界面简洁、入口清晰</a:t>
+              <a:defRPr sz="1700">
+                <a:solidFill>
+                  <a:srgbClr val="464646"/>
+                </a:solidFill>
+              </a:defRPr>
+            </a:pPr>
+            <a:r>
+              <a:t>CRUD能力覆盖核心业务场景</a:t>
             </a:r>
           </a:p>
         </p:txBody>
@@ -4672,13 +6173,13 @@
         <p:spPr>
           <a:xfrm>
             <a:off x="0" y="0"/>
-            <a:ext cx="12191695" cy="502920"/>
+            <a:ext cx="12191695" cy="438912"/>
           </a:xfrm>
           <a:prstGeom prst="rect">
             <a:avLst/>
           </a:prstGeom>
           <a:solidFill>
-            <a:srgbClr val="20253A"/>
+            <a:srgbClr val="22293F"/>
           </a:solidFill>
           <a:ln>
             <a:noFill/>
@@ -4714,8 +6215,8 @@
         </p:nvSpPr>
         <p:spPr>
           <a:xfrm>
-            <a:off x="640080" y="658368"/>
-            <a:ext cx="10972800" cy="731520"/>
+            <a:off x="640080" y="603504"/>
+            <a:ext cx="10972800" cy="914400"/>
           </a:xfrm>
           <a:prstGeom prst="rect">
             <a:avLst/>
@@ -4731,24 +6232,12 @@
             <a:pPr>
               <a:defRPr sz="3400" b="1">
                 <a:solidFill>
-                  <a:srgbClr val="20253A"/>
-                </a:solidFill>
-              </a:defRPr>
-            </a:pPr>
-            <a:r>
-              <a:t>学生端核心功能</a:t>
-            </a:r>
-          </a:p>
-          <a:p>
-            <a:pPr>
-              <a:defRPr sz="1500">
-                <a:solidFill>
-                  <a:srgbClr val="373737"/>
-                </a:solidFill>
-              </a:defRPr>
-            </a:pPr>
-            <a:r>
-              <a:t>报名与评价形成参与闭环</a:t>
+                  <a:srgbClr val="22293F"/>
+                </a:solidFill>
+              </a:defRPr>
+            </a:pPr>
+            <a:r>
+              <a:t>数据库设计思路</a:t>
             </a:r>
           </a:p>
         </p:txBody>
@@ -4761,18 +6250,18 @@
         </p:nvSpPr>
         <p:spPr>
           <a:xfrm>
-            <a:off x="731520" y="1645920"/>
-            <a:ext cx="5577840" cy="4480560"/>
+            <a:off x="822960" y="1691640"/>
+            <a:ext cx="5303520" cy="4480560"/>
           </a:xfrm>
           <a:prstGeom prst="roundRect">
             <a:avLst/>
           </a:prstGeom>
           <a:solidFill>
-            <a:srgbClr val="E8ECF5"/>
+            <a:srgbClr val="FFFFFF"/>
           </a:solidFill>
           <a:ln>
             <a:solidFill>
-              <a:srgbClr val="BEC6DC"/>
+              <a:srgbClr val="DCE2F0"/>
             </a:solidFill>
           </a:ln>
         </p:spPr>
@@ -4795,26 +6284,74 @@
           <a:lstStyle/>
           <a:p>
             <a:pPr algn="ctr">
-              <a:defRPr b="1" sz="2000">
-                <a:solidFill>
-                  <a:srgbClr val="20253A"/>
-                </a:solidFill>
-              </a:defRPr>
-            </a:pPr>
-            <a:r>
-              <a:t>待插入截图：学生课程/活动报名</a:t>
-            </a:r>
-          </a:p>
-          <a:p>
-            <a:pPr algn="ctr">
-              <a:defRPr sz="1000">
-                <a:solidFill>
-                  <a:srgbClr val="5A5A5A"/>
-                </a:solidFill>
-              </a:defRPr>
-            </a:pPr>
-            <a:r>
-              <a:t>https://github.com/user-attachments/assets/3ecd8d9a-82a2-45f9-9e61-11e03d87add2</a:t>
+              <a:defRPr sz="2200" b="1">
+                <a:solidFill>
+                  <a:srgbClr val="22293F"/>
+                </a:solidFill>
+              </a:defRPr>
+            </a:pPr>
+            <a:r>
+              <a:t>核心实体</a:t>
+            </a:r>
+          </a:p>
+          <a:p>
+            <a:pPr>
+              <a:defRPr sz="1700">
+                <a:solidFill>
+                  <a:srgbClr val="464646"/>
+                </a:solidFill>
+              </a:defRPr>
+            </a:pPr>
+            <a:r>
+              <a:t>用户（User）</a:t>
+            </a:r>
+          </a:p>
+          <a:p>
+            <a:pPr>
+              <a:defRPr sz="1700">
+                <a:solidFill>
+                  <a:srgbClr val="464646"/>
+                </a:solidFill>
+              </a:defRPr>
+            </a:pPr>
+            <a:r>
+              <a:t>教师（Teacher）</a:t>
+            </a:r>
+          </a:p>
+          <a:p>
+            <a:pPr>
+              <a:defRPr sz="1700">
+                <a:solidFill>
+                  <a:srgbClr val="464646"/>
+                </a:solidFill>
+              </a:defRPr>
+            </a:pPr>
+            <a:r>
+              <a:t>学生（Student）</a:t>
+            </a:r>
+          </a:p>
+          <a:p>
+            <a:pPr>
+              <a:defRPr sz="1700">
+                <a:solidFill>
+                  <a:srgbClr val="464646"/>
+                </a:solidFill>
+              </a:defRPr>
+            </a:pPr>
+            <a:r>
+              <a:t>课程活动（Course）</a:t>
+            </a:r>
+          </a:p>
+          <a:p>
+            <a:pPr>
+              <a:defRPr sz="1700">
+                <a:solidFill>
+                  <a:srgbClr val="464646"/>
+                </a:solidFill>
+              </a:defRPr>
+            </a:pPr>
+            <a:r>
+              <a:t>选课关联（Scourse）</a:t>
             </a:r>
           </a:p>
         </p:txBody>
@@ -4827,18 +6364,18 @@
         </p:nvSpPr>
         <p:spPr>
           <a:xfrm>
-            <a:off x="6355080" y="1645920"/>
-            <a:ext cx="5074920" cy="4480560"/>
+            <a:off x="6035040" y="1691640"/>
+            <a:ext cx="5303520" cy="4480560"/>
           </a:xfrm>
           <a:prstGeom prst="roundRect">
             <a:avLst/>
           </a:prstGeom>
           <a:solidFill>
-            <a:srgbClr val="E8ECF5"/>
+            <a:srgbClr val="FFFFFF"/>
           </a:solidFill>
           <a:ln>
             <a:solidFill>
-              <a:srgbClr val="BEC6DC"/>
+              <a:srgbClr val="DCE2F0"/>
             </a:solidFill>
           </a:ln>
         </p:spPr>
@@ -4861,26 +6398,50 @@
           <a:lstStyle/>
           <a:p>
             <a:pPr algn="ctr">
-              <a:defRPr b="1" sz="2000">
-                <a:solidFill>
-                  <a:srgbClr val="20253A"/>
-                </a:solidFill>
-              </a:defRPr>
-            </a:pPr>
-            <a:r>
-              <a:t>待插入截图：学生课程/活动评价</a:t>
-            </a:r>
-          </a:p>
-          <a:p>
-            <a:pPr algn="ctr">
-              <a:defRPr sz="1000">
-                <a:solidFill>
-                  <a:srgbClr val="5A5A5A"/>
-                </a:solidFill>
-              </a:defRPr>
-            </a:pPr>
-            <a:r>
-              <a:t>https://github.com/user-attachments/assets/a8ec555e-ddb2-43a0-a4dc-4c08d01b3751</a:t>
+              <a:defRPr sz="2200" b="1">
+                <a:solidFill>
+                  <a:srgbClr val="22293F"/>
+                </a:solidFill>
+              </a:defRPr>
+            </a:pPr>
+            <a:r>
+              <a:t>关系与约束</a:t>
+            </a:r>
+          </a:p>
+          <a:p>
+            <a:pPr>
+              <a:defRPr sz="1700">
+                <a:solidFill>
+                  <a:srgbClr val="464646"/>
+                </a:solidFill>
+              </a:defRPr>
+            </a:pPr>
+            <a:r>
+              <a:t>一人一角色（或扩展多角色）</a:t>
+            </a:r>
+          </a:p>
+          <a:p>
+            <a:pPr>
+              <a:defRPr sz="1700">
+                <a:solidFill>
+                  <a:srgbClr val="464646"/>
+                </a:solidFill>
+              </a:defRPr>
+            </a:pPr>
+            <a:r>
+              <a:t>课程与学生多对多关联</a:t>
+            </a:r>
+          </a:p>
+          <a:p>
+            <a:pPr>
+              <a:defRPr sz="1700">
+                <a:solidFill>
+                  <a:srgbClr val="464646"/>
+                </a:solidFill>
+              </a:defRPr>
+            </a:pPr>
+            <a:r>
+              <a:t>成绩与考勤依赖报名记录</a:t>
             </a:r>
           </a:p>
         </p:txBody>
@@ -4955,13 +6516,13 @@
         <p:spPr>
           <a:xfrm>
             <a:off x="0" y="0"/>
-            <a:ext cx="12191695" cy="502920"/>
+            <a:ext cx="12191695" cy="438912"/>
           </a:xfrm>
           <a:prstGeom prst="rect">
             <a:avLst/>
           </a:prstGeom>
           <a:solidFill>
-            <a:srgbClr val="20253A"/>
+            <a:srgbClr val="22293F"/>
           </a:solidFill>
           <a:ln>
             <a:noFill/>
@@ -4997,8 +6558,8 @@
         </p:nvSpPr>
         <p:spPr>
           <a:xfrm>
-            <a:off x="640080" y="658368"/>
-            <a:ext cx="10972800" cy="731520"/>
+            <a:off x="640080" y="603504"/>
+            <a:ext cx="10972800" cy="914400"/>
           </a:xfrm>
           <a:prstGeom prst="rect">
             <a:avLst/>
@@ -5014,24 +6575,12 @@
             <a:pPr>
               <a:defRPr sz="3400" b="1">
                 <a:solidFill>
-                  <a:srgbClr val="20253A"/>
-                </a:solidFill>
-              </a:defRPr>
-            </a:pPr>
-            <a:r>
-              <a:t>教师端核心功能</a:t>
-            </a:r>
-          </a:p>
-          <a:p>
-            <a:pPr>
-              <a:defRPr sz="1500">
-                <a:solidFill>
-                  <a:srgbClr val="373737"/>
-                </a:solidFill>
-              </a:defRPr>
-            </a:pPr>
-            <a:r>
-              <a:t>课程组织与过程管理</a:t>
+                  <a:srgbClr val="22293F"/>
+                </a:solidFill>
+              </a:defRPr>
+            </a:pPr>
+            <a:r>
+              <a:t>登录与系统入口</a:t>
             </a:r>
           </a:p>
         </p:txBody>
@@ -5045,7 +6594,7 @@
         <p:spPr>
           <a:xfrm>
             <a:off x="731520" y="1645920"/>
-            <a:ext cx="5577840" cy="2240280"/>
+            <a:ext cx="7498079" cy="4754880"/>
           </a:xfrm>
           <a:prstGeom prst="roundRect">
             <a:avLst/>
@@ -5078,26 +6627,26 @@
           <a:lstStyle/>
           <a:p>
             <a:pPr algn="ctr">
-              <a:defRPr b="1" sz="2000">
-                <a:solidFill>
-                  <a:srgbClr val="20253A"/>
-                </a:solidFill>
-              </a:defRPr>
-            </a:pPr>
-            <a:r>
-              <a:t>待插入截图：教师课程/活动管理</a:t>
+              <a:defRPr b="1" sz="1800">
+                <a:solidFill>
+                  <a:srgbClr val="22293F"/>
+                </a:solidFill>
+              </a:defRPr>
+            </a:pPr>
+            <a:r>
+              <a:t>待插入：登录页面</a:t>
             </a:r>
           </a:p>
           <a:p>
             <a:pPr algn="ctr">
-              <a:defRPr sz="1000">
-                <a:solidFill>
-                  <a:srgbClr val="5A5A5A"/>
-                </a:solidFill>
-              </a:defRPr>
-            </a:pPr>
-            <a:r>
-              <a:t>https://github.com/user-attachments/assets/d2089224-643f-491f-a304-a48b0c04a6c5</a:t>
+              <a:defRPr sz="900">
+                <a:solidFill>
+                  <a:srgbClr val="464646"/>
+                </a:solidFill>
+              </a:defRPr>
+            </a:pPr>
+            <a:r>
+              <a:t>https://github.com/user-attachments/assets/d5695ebd-ffb9-4766-93e6-bef8c12eaf6c</a:t>
             </a:r>
           </a:p>
         </p:txBody>
@@ -5110,18 +6659,18 @@
         </p:nvSpPr>
         <p:spPr>
           <a:xfrm>
-            <a:off x="6355080" y="1645920"/>
-            <a:ext cx="5074920" cy="2240280"/>
+            <a:off x="8366760" y="1828800"/>
+            <a:ext cx="2834640" cy="4389120"/>
           </a:xfrm>
           <a:prstGeom prst="roundRect">
             <a:avLst/>
           </a:prstGeom>
           <a:solidFill>
-            <a:srgbClr val="E8ECF5"/>
+            <a:srgbClr val="FFFFFF"/>
           </a:solidFill>
           <a:ln>
             <a:solidFill>
-              <a:srgbClr val="BEC6DC"/>
+              <a:srgbClr val="DCE2F0"/>
             </a:solidFill>
           </a:ln>
         </p:spPr>
@@ -5144,92 +6693,50 @@
           <a:lstStyle/>
           <a:p>
             <a:pPr algn="ctr">
-              <a:defRPr b="1" sz="2000">
-                <a:solidFill>
-                  <a:srgbClr val="20253A"/>
-                </a:solidFill>
-              </a:defRPr>
-            </a:pPr>
-            <a:r>
-              <a:t>待插入截图：成绩录入</a:t>
-            </a:r>
-          </a:p>
-          <a:p>
-            <a:pPr algn="ctr">
-              <a:defRPr sz="1000">
-                <a:solidFill>
-                  <a:srgbClr val="5A5A5A"/>
-                </a:solidFill>
-              </a:defRPr>
-            </a:pPr>
-            <a:r>
-              <a:t>https://github.com/user-attachments/assets/94de7b8c-ff84-47ab-ab47-2a2df7e89495</a:t>
-            </a:r>
-          </a:p>
-        </p:txBody>
-      </p:sp>
-      <p:sp>
-        <p:nvSpPr>
-          <p:cNvPr id="7" name="Rounded Rectangle 6"/>
-          <p:cNvSpPr/>
-          <p:nvPr/>
-        </p:nvSpPr>
-        <p:spPr>
-          <a:xfrm>
-            <a:off x="6355080" y="3886200"/>
-            <a:ext cx="5074920" cy="2240280"/>
-          </a:xfrm>
-          <a:prstGeom prst="roundRect">
-            <a:avLst/>
-          </a:prstGeom>
-          <a:solidFill>
-            <a:srgbClr val="E8ECF5"/>
-          </a:solidFill>
-          <a:ln>
-            <a:solidFill>
-              <a:srgbClr val="BEC6DC"/>
-            </a:solidFill>
-          </a:ln>
-        </p:spPr>
-        <p:style>
-          <a:lnRef idx="1">
-            <a:schemeClr val="accent1"/>
-          </a:lnRef>
-          <a:fillRef idx="3">
-            <a:schemeClr val="accent1"/>
-          </a:fillRef>
-          <a:effectRef idx="2">
-            <a:schemeClr val="accent1"/>
-          </a:effectRef>
-          <a:fontRef idx="minor">
-            <a:schemeClr val="lt1"/>
-          </a:fontRef>
-        </p:style>
-        <p:txBody>
-          <a:bodyPr rtlCol="0" anchor="ctr"/>
-          <a:lstStyle/>
-          <a:p>
-            <a:pPr algn="ctr">
-              <a:defRPr b="1" sz="2000">
-                <a:solidFill>
-                  <a:srgbClr val="20253A"/>
-                </a:solidFill>
-              </a:defRPr>
-            </a:pPr>
-            <a:r>
-              <a:t>待插入截图：考勤管理</a:t>
-            </a:r>
-          </a:p>
-          <a:p>
-            <a:pPr algn="ctr">
-              <a:defRPr sz="1000">
-                <a:solidFill>
-                  <a:srgbClr val="5A5A5A"/>
-                </a:solidFill>
-              </a:defRPr>
-            </a:pPr>
-            <a:r>
-              <a:t>https://github.com/user-attachments/assets/4d44de09-7e1b-455e-9dbd-b06c2b20031b</a:t>
+              <a:defRPr sz="2200" b="1">
+                <a:solidFill>
+                  <a:srgbClr val="22293F"/>
+                </a:solidFill>
+              </a:defRPr>
+            </a:pPr>
+            <a:r>
+              <a:t>说明</a:t>
+            </a:r>
+          </a:p>
+          <a:p>
+            <a:pPr>
+              <a:defRPr sz="1700">
+                <a:solidFill>
+                  <a:srgbClr val="464646"/>
+                </a:solidFill>
+              </a:defRPr>
+            </a:pPr>
+            <a:r>
+              <a:t>统一认证入口</a:t>
+            </a:r>
+          </a:p>
+          <a:p>
+            <a:pPr>
+              <a:defRPr sz="1700">
+                <a:solidFill>
+                  <a:srgbClr val="464646"/>
+                </a:solidFill>
+              </a:defRPr>
+            </a:pPr>
+            <a:r>
+              <a:t>支持按角色进入功能域</a:t>
+            </a:r>
+          </a:p>
+          <a:p>
+            <a:pPr>
+              <a:defRPr sz="1700">
+                <a:solidFill>
+                  <a:srgbClr val="464646"/>
+                </a:solidFill>
+              </a:defRPr>
+            </a:pPr>
+            <a:r>
+              <a:t>界面简洁，使用门槛低</a:t>
             </a:r>
           </a:p>
         </p:txBody>
@@ -5304,13 +6811,13 @@
         <p:spPr>
           <a:xfrm>
             <a:off x="0" y="0"/>
-            <a:ext cx="12191695" cy="502920"/>
+            <a:ext cx="12191695" cy="438912"/>
           </a:xfrm>
           <a:prstGeom prst="rect">
             <a:avLst/>
           </a:prstGeom>
           <a:solidFill>
-            <a:srgbClr val="20253A"/>
+            <a:srgbClr val="22293F"/>
           </a:solidFill>
           <a:ln>
             <a:noFill/>
@@ -5346,8 +6853,8 @@
         </p:nvSpPr>
         <p:spPr>
           <a:xfrm>
-            <a:off x="640080" y="658368"/>
-            <a:ext cx="10972800" cy="731520"/>
+            <a:off x="640080" y="603504"/>
+            <a:ext cx="10972800" cy="914400"/>
           </a:xfrm>
           <a:prstGeom prst="rect">
             <a:avLst/>
@@ -5363,24 +6870,12 @@
             <a:pPr>
               <a:defRPr sz="3400" b="1">
                 <a:solidFill>
-                  <a:srgbClr val="20253A"/>
-                </a:solidFill>
-              </a:defRPr>
-            </a:pPr>
-            <a:r>
-              <a:t>管理员端核心功能</a:t>
-            </a:r>
-          </a:p>
-          <a:p>
-            <a:pPr>
-              <a:defRPr sz="1500">
-                <a:solidFill>
-                  <a:srgbClr val="373737"/>
-                </a:solidFill>
-              </a:defRPr>
-            </a:pPr>
-            <a:r>
-              <a:t>用户管理保障平台稳定运行</a:t>
+                  <a:srgbClr val="22293F"/>
+                </a:solidFill>
+              </a:defRPr>
+            </a:pPr>
+            <a:r>
+              <a:t>教师端：课程/活动管理</a:t>
             </a:r>
           </a:p>
         </p:txBody>
@@ -5393,8 +6888,8 @@
         </p:nvSpPr>
         <p:spPr>
           <a:xfrm>
-            <a:off x="777240" y="1645920"/>
-            <a:ext cx="7498079" cy="4754880"/>
+            <a:off x="731520" y="1645920"/>
+            <a:ext cx="10789920" cy="4754880"/>
           </a:xfrm>
           <a:prstGeom prst="roundRect">
             <a:avLst/>
@@ -5427,128 +6922,26 @@
           <a:lstStyle/>
           <a:p>
             <a:pPr algn="ctr">
-              <a:defRPr b="1" sz="2000">
-                <a:solidFill>
-                  <a:srgbClr val="20253A"/>
-                </a:solidFill>
-              </a:defRPr>
-            </a:pPr>
-            <a:r>
-              <a:t>待插入截图：管理员用户管理</a:t>
+              <a:defRPr b="1" sz="1800">
+                <a:solidFill>
+                  <a:srgbClr val="22293F"/>
+                </a:solidFill>
+              </a:defRPr>
+            </a:pPr>
+            <a:r>
+              <a:t>待插入：课程/活动管理</a:t>
             </a:r>
           </a:p>
           <a:p>
             <a:pPr algn="ctr">
-              <a:defRPr sz="1000">
-                <a:solidFill>
-                  <a:srgbClr val="5A5A5A"/>
-                </a:solidFill>
-              </a:defRPr>
-            </a:pPr>
-            <a:r>
-              <a:t>https://github.com/user-attachments/assets/a4a8e15f-ff50-4b5b-8f90-be961cac541b</a:t>
-            </a:r>
-          </a:p>
-        </p:txBody>
-      </p:sp>
-      <p:sp>
-        <p:nvSpPr>
-          <p:cNvPr id="6" name="Rounded Rectangle 5"/>
-          <p:cNvSpPr/>
-          <p:nvPr/>
-        </p:nvSpPr>
-        <p:spPr>
-          <a:xfrm>
-            <a:off x="8412480" y="1828800"/>
-            <a:ext cx="3108960" cy="4389120"/>
-          </a:xfrm>
-          <a:prstGeom prst="roundRect">
-            <a:avLst/>
-          </a:prstGeom>
-          <a:solidFill>
-            <a:srgbClr val="FFFFFF"/>
-          </a:solidFill>
-          <a:ln>
-            <a:solidFill>
-              <a:srgbClr val="DCE2F0"/>
-            </a:solidFill>
-          </a:ln>
-        </p:spPr>
-        <p:style>
-          <a:lnRef idx="1">
-            <a:schemeClr val="accent1"/>
-          </a:lnRef>
-          <a:fillRef idx="3">
-            <a:schemeClr val="accent1"/>
-          </a:fillRef>
-          <a:effectRef idx="2">
-            <a:schemeClr val="accent1"/>
-          </a:effectRef>
-          <a:fontRef idx="minor">
-            <a:schemeClr val="lt1"/>
-          </a:fontRef>
-        </p:style>
-        <p:txBody>
-          <a:bodyPr rtlCol="0" anchor="ctr"/>
-          <a:lstStyle/>
-          <a:p>
-            <a:pPr algn="ctr">
-              <a:spcAft>
-                <a:spcPts val="1000"/>
-              </a:spcAft>
-              <a:defRPr sz="2000" b="1">
-                <a:solidFill>
-                  <a:srgbClr val="20253A"/>
-                </a:solidFill>
-              </a:defRPr>
-            </a:pPr>
-            <a:r>
-              <a:t>管理价值</a:t>
-            </a:r>
-          </a:p>
-          <a:p>
-            <a:pPr>
-              <a:spcAft>
-                <a:spcPts val="1000"/>
-              </a:spcAft>
-              <a:defRPr sz="1800" b="0">
-                <a:solidFill>
-                  <a:srgbClr val="373737"/>
-                </a:solidFill>
-              </a:defRPr>
-            </a:pPr>
-            <a:r>
-              <a:t>用户信息集中维护</a:t>
-            </a:r>
-          </a:p>
-          <a:p>
-            <a:pPr>
-              <a:spcAft>
-                <a:spcPts val="1000"/>
-              </a:spcAft>
-              <a:defRPr sz="1800" b="0">
-                <a:solidFill>
-                  <a:srgbClr val="373737"/>
-                </a:solidFill>
-              </a:defRPr>
-            </a:pPr>
-            <a:r>
-              <a:t>角色权限配置更清晰</a:t>
-            </a:r>
-          </a:p>
-          <a:p>
-            <a:pPr>
-              <a:spcAft>
-                <a:spcPts val="1000"/>
-              </a:spcAft>
-              <a:defRPr sz="1800" b="0">
-                <a:solidFill>
-                  <a:srgbClr val="373737"/>
-                </a:solidFill>
-              </a:defRPr>
-            </a:pPr>
-            <a:r>
-              <a:t>支持系统日常运维</a:t>
+              <a:defRPr sz="900">
+                <a:solidFill>
+                  <a:srgbClr val="464646"/>
+                </a:solidFill>
+              </a:defRPr>
+            </a:pPr>
+            <a:r>
+              <a:t>https://github.com/user-attachments/assets/d2089224-643f-491f-a304-a48b0c04a6c5</a:t>
             </a:r>
           </a:p>
         </p:txBody>
@@ -5623,13 +7016,13 @@
         <p:spPr>
           <a:xfrm>
             <a:off x="0" y="0"/>
-            <a:ext cx="12191695" cy="502920"/>
+            <a:ext cx="12191695" cy="438912"/>
           </a:xfrm>
           <a:prstGeom prst="rect">
             <a:avLst/>
           </a:prstGeom>
           <a:solidFill>
-            <a:srgbClr val="20253A"/>
+            <a:srgbClr val="22293F"/>
           </a:solidFill>
           <a:ln>
             <a:noFill/>
@@ -5665,8 +7058,8 @@
         </p:nvSpPr>
         <p:spPr>
           <a:xfrm>
-            <a:off x="640080" y="658368"/>
-            <a:ext cx="10972800" cy="731520"/>
+            <a:off x="640080" y="603504"/>
+            <a:ext cx="10972800" cy="914400"/>
           </a:xfrm>
           <a:prstGeom prst="rect">
             <a:avLst/>
@@ -5682,12 +7075,12 @@
             <a:pPr>
               <a:defRPr sz="3400" b="1">
                 <a:solidFill>
-                  <a:srgbClr val="20253A"/>
-                </a:solidFill>
-              </a:defRPr>
-            </a:pPr>
-            <a:r>
-              <a:t>技术实现与项目亮点</a:t>
+                  <a:srgbClr val="22293F"/>
+                </a:solidFill>
+              </a:defRPr>
+            </a:pPr>
+            <a:r>
+              <a:t>教师端：课程管理能力拆解</a:t>
             </a:r>
           </a:p>
         </p:txBody>
@@ -5700,8 +7093,8 @@
         </p:nvSpPr>
         <p:spPr>
           <a:xfrm>
-            <a:off x="822960" y="1645920"/>
-            <a:ext cx="5303520" cy="4480560"/>
+            <a:off x="822960" y="1737360"/>
+            <a:ext cx="3749039" cy="4389120"/>
           </a:xfrm>
           <a:prstGeom prst="roundRect">
             <a:avLst/>
@@ -5734,62 +7127,50 @@
           <a:lstStyle/>
           <a:p>
             <a:pPr algn="ctr">
-              <a:spcAft>
-                <a:spcPts val="1000"/>
-              </a:spcAft>
-              <a:defRPr sz="2000" b="1">
-                <a:solidFill>
-                  <a:srgbClr val="20253A"/>
-                </a:solidFill>
-              </a:defRPr>
-            </a:pPr>
-            <a:r>
-              <a:t>技术栈</a:t>
+              <a:defRPr sz="2200" b="1">
+                <a:solidFill>
+                  <a:srgbClr val="22293F"/>
+                </a:solidFill>
+              </a:defRPr>
+            </a:pPr>
+            <a:r>
+              <a:t>业务动作</a:t>
             </a:r>
           </a:p>
           <a:p>
             <a:pPr>
-              <a:spcAft>
-                <a:spcPts val="1000"/>
-              </a:spcAft>
-              <a:defRPr sz="1800" b="0">
-                <a:solidFill>
-                  <a:srgbClr val="373737"/>
-                </a:solidFill>
-              </a:defRPr>
-            </a:pPr>
-            <a:r>
-              <a:t>后端：Java + Spring + Spring MVC + MyBatis</a:t>
+              <a:defRPr sz="1700">
+                <a:solidFill>
+                  <a:srgbClr val="464646"/>
+                </a:solidFill>
+              </a:defRPr>
+            </a:pPr>
+            <a:r>
+              <a:t>新增课程/活动</a:t>
             </a:r>
           </a:p>
           <a:p>
             <a:pPr>
-              <a:spcAft>
-                <a:spcPts val="1000"/>
-              </a:spcAft>
-              <a:defRPr sz="1800" b="0">
-                <a:solidFill>
-                  <a:srgbClr val="373737"/>
-                </a:solidFill>
-              </a:defRPr>
-            </a:pPr>
-            <a:r>
-              <a:t>前端：JSP + Bootstrap/AdminLTE</a:t>
+              <a:defRPr sz="1700">
+                <a:solidFill>
+                  <a:srgbClr val="464646"/>
+                </a:solidFill>
+              </a:defRPr>
+            </a:pPr>
+            <a:r>
+              <a:t>编辑课程信息</a:t>
             </a:r>
           </a:p>
           <a:p>
             <a:pPr>
-              <a:spcAft>
-                <a:spcPts val="1000"/>
-              </a:spcAft>
-              <a:defRPr sz="1800" b="0">
-                <a:solidFill>
-                  <a:srgbClr val="373737"/>
-                </a:solidFill>
-              </a:defRPr>
-            </a:pPr>
-            <a:r>
-              <a:t>数据库：MySQL</a:t>
+              <a:defRPr sz="1700">
+                <a:solidFill>
+                  <a:srgbClr val="464646"/>
+                </a:solidFill>
+              </a:defRPr>
+            </a:pPr>
+            <a:r>
+              <a:t>删除无效课程</a:t>
             </a:r>
           </a:p>
         </p:txBody>
@@ -5802,8 +7183,8 @@
         </p:nvSpPr>
         <p:spPr>
           <a:xfrm>
-            <a:off x="6035040" y="1645920"/>
-            <a:ext cx="5303520" cy="4480560"/>
+            <a:off x="4709160" y="1737360"/>
+            <a:ext cx="3749039" cy="4389120"/>
           </a:xfrm>
           <a:prstGeom prst="roundRect">
             <a:avLst/>
@@ -5836,62 +7217,116 @@
           <a:lstStyle/>
           <a:p>
             <a:pPr algn="ctr">
-              <a:spcAft>
-                <a:spcPts val="1000"/>
-              </a:spcAft>
-              <a:defRPr sz="2000" b="1">
-                <a:solidFill>
-                  <a:srgbClr val="20253A"/>
-                </a:solidFill>
-              </a:defRPr>
-            </a:pPr>
-            <a:r>
-              <a:t>项目亮点</a:t>
+              <a:defRPr sz="2200" b="1">
+                <a:solidFill>
+                  <a:srgbClr val="22293F"/>
+                </a:solidFill>
+              </a:defRPr>
+            </a:pPr>
+            <a:r>
+              <a:t>界面价值</a:t>
             </a:r>
           </a:p>
           <a:p>
             <a:pPr>
-              <a:spcAft>
-                <a:spcPts val="1000"/>
-              </a:spcAft>
-              <a:defRPr sz="1800" b="0">
-                <a:solidFill>
-                  <a:srgbClr val="373737"/>
-                </a:solidFill>
-              </a:defRPr>
-            </a:pPr>
-            <a:r>
-              <a:t>多角色业务流程清晰</a:t>
+              <a:defRPr sz="1700">
+                <a:solidFill>
+                  <a:srgbClr val="464646"/>
+                </a:solidFill>
+              </a:defRPr>
+            </a:pPr>
+            <a:r>
+              <a:t>列表化管理提高可读性</a:t>
             </a:r>
           </a:p>
           <a:p>
             <a:pPr>
-              <a:spcAft>
-                <a:spcPts val="1000"/>
-              </a:spcAft>
-              <a:defRPr sz="1800" b="0">
-                <a:solidFill>
-                  <a:srgbClr val="373737"/>
-                </a:solidFill>
-              </a:defRPr>
-            </a:pPr>
-            <a:r>
-              <a:t>功能覆盖“报名-管理-考勤-成绩-评价”</a:t>
+              <a:defRPr sz="1700">
+                <a:solidFill>
+                  <a:srgbClr val="464646"/>
+                </a:solidFill>
+              </a:defRPr>
+            </a:pPr>
+            <a:r>
+              <a:t>操作按钮聚焦常用动作</a:t>
             </a:r>
           </a:p>
           <a:p>
             <a:pPr>
-              <a:spcAft>
-                <a:spcPts val="1000"/>
-              </a:spcAft>
-              <a:defRPr sz="1800" b="0">
-                <a:solidFill>
-                  <a:srgbClr val="373737"/>
-                </a:solidFill>
-              </a:defRPr>
-            </a:pPr>
-            <a:r>
-              <a:t>页面统一，操作路径简洁</a:t>
+              <a:defRPr sz="1700">
+                <a:solidFill>
+                  <a:srgbClr val="464646"/>
+                </a:solidFill>
+              </a:defRPr>
+            </a:pPr>
+            <a:r>
+              <a:t>减少教师维护成本</a:t>
+            </a:r>
+          </a:p>
+        </p:txBody>
+      </p:sp>
+      <p:sp>
+        <p:nvSpPr>
+          <p:cNvPr id="7" name="Rounded Rectangle 6"/>
+          <p:cNvSpPr/>
+          <p:nvPr/>
+        </p:nvSpPr>
+        <p:spPr>
+          <a:xfrm>
+            <a:off x="8595360" y="1828800"/>
+            <a:ext cx="2743200" cy="4206240"/>
+          </a:xfrm>
+          <a:prstGeom prst="roundRect">
+            <a:avLst/>
+          </a:prstGeom>
+          <a:solidFill>
+            <a:srgbClr val="E8ECF5"/>
+          </a:solidFill>
+          <a:ln>
+            <a:solidFill>
+              <a:srgbClr val="BEC6DC"/>
+            </a:solidFill>
+          </a:ln>
+        </p:spPr>
+        <p:style>
+          <a:lnRef idx="1">
+            <a:schemeClr val="accent1"/>
+          </a:lnRef>
+          <a:fillRef idx="3">
+            <a:schemeClr val="accent1"/>
+          </a:fillRef>
+          <a:effectRef idx="2">
+            <a:schemeClr val="accent1"/>
+          </a:effectRef>
+          <a:fontRef idx="minor">
+            <a:schemeClr val="lt1"/>
+          </a:fontRef>
+        </p:style>
+        <p:txBody>
+          <a:bodyPr rtlCol="0" anchor="ctr"/>
+          <a:lstStyle/>
+          <a:p>
+            <a:pPr algn="ctr">
+              <a:defRPr b="1" sz="1800">
+                <a:solidFill>
+                  <a:srgbClr val="22293F"/>
+                </a:solidFill>
+              </a:defRPr>
+            </a:pPr>
+            <a:r>
+              <a:t>待插入：课程管理页面</a:t>
+            </a:r>
+          </a:p>
+          <a:p>
+            <a:pPr algn="ctr">
+              <a:defRPr sz="900">
+                <a:solidFill>
+                  <a:srgbClr val="464646"/>
+                </a:solidFill>
+              </a:defRPr>
+            </a:pPr>
+            <a:r>
+              <a:t>https://github.com/user-attachments/assets/d2089224-643f-491f-a304-a48b0c04a6c5</a:t>
             </a:r>
           </a:p>
         </p:txBody>

</xml_diff>